<commit_message>
feat: add customer demo runbook and per-capability tour script
Adds RUNBOOK.md with pre-flight checks, talk track, and exact commands
for presenting the demo live, plus capability_tour.py exercising each
generated tool class individually (lookup, filter, search, count,
summarize, expand/relationship-traversal) -- verified live against the
Context Retriever service. Corrects the spec's now-stale open question
about relationship declaration, and documents the real count_*/
summarize_*/expand_results schemas discovered while building the tour.

Co-Authored-By: Claude Sonnet 5 <noreply@anthropic.com>
</commit_message>
<xml_diff>
--- a/Context-Retriever-Payment-Failure-Demo.pptx
+++ b/Context-Retriever-Payment-Failure-Demo.pptx
@@ -4,6 +4,9 @@
   <p:sldMasterIdLst>
     <p:sldMasterId id="2147483648" r:id="rId1"/>
   </p:sldMasterIdLst>
+  <p:notesMasterIdLst>
+    <p:notesMasterId r:id="rId21"/>
+  </p:notesMasterIdLst>
   <p:sldIdLst>
     <p:sldId id="256" r:id="rId2"/>
     <p:sldId id="257" r:id="rId3"/>
@@ -25,10 +28,7 @@
     <p:sldId id="273" r:id="rId19"/>
     <p:sldId id="274" r:id="rId20"/>
   </p:sldIdLst>
-  <p:notesMasterIdLst>
-    <p:notesMasterId r:id="rId21"/>
-  </p:notesMasterIdLst>
-  <p:sldSz cx="9144000" cy="5143500"/>
+  <p:sldSz cx="9144000" cy="5143500" type="screen16x9"/>
   <p:notesSz cx="5143500" cy="9144000"/>
   <p:defaultTextStyle>
     <a:lvl1pPr marL="0" algn="l" defTabSz="914400" rtl="0" eaLnBrk="1" latinLnBrk="0" hangingPunct="1">
@@ -122,6 +122,11 @@
       </a:defRPr>
     </a:lvl9pPr>
   </p:defaultTextStyle>
+  <p:extLst>
+    <p:ext uri="{EFAFB233-063F-42B5-8137-9DF3F51BA10A}">
+      <p15:sldGuideLst xmlns:p15="http://schemas.microsoft.com/office/powerpoint/2012/main"/>
+    </p:ext>
+  </p:extLst>
 </p:presentation>
 </file>
 
@@ -147,234 +152,10 @@
           <a:chExt cx="0" cy="0"/>
         </a:xfrm>
       </p:grpSpPr>
-      <p:sp>
-        <p:nvSpPr>
-          <p:cNvPr id="2" name="Header Placeholder 1"/>
-          <p:cNvSpPr>
-            <a:spLocks noGrp="1"/>
-          </p:cNvSpPr>
-          <p:nvPr>
-            <p:ph type="hdr" sz="quarter"/>
-          </p:nvPr>
-        </p:nvSpPr>
-        <p:spPr>
-          <a:xfrm>
-            <a:off x="0" y="0"/>
-            <a:ext cx="2971800" cy="458788"/>
-          </a:xfrm>
-          <a:prstGeom prst="rect">
-            <a:avLst/>
-          </a:prstGeom>
-        </p:spPr>
-        <p:txBody>
-          <a:bodyPr vert="horz" lIns="91440" tIns="45720" rIns="91440" bIns="45720" rtlCol="0"/>
-          <a:lstStyle>
-            <a:lvl1pPr algn="l">
-              <a:defRPr sz="1200"/>
-            </a:lvl1pPr>
-          </a:lstStyle>
-          <a:p>
-            <a:endParaRPr lang="en-US"/>
-          </a:p>
-        </p:txBody>
-      </p:sp>
-      <p:sp>
-        <p:nvSpPr>
-          <p:cNvPr id="3" name="Date Placeholder 2"/>
-          <p:cNvSpPr>
-            <a:spLocks noGrp="1"/>
-          </p:cNvSpPr>
-          <p:nvPr>
-            <p:ph type="dt" idx="1"/>
-          </p:nvPr>
-        </p:nvSpPr>
-        <p:spPr>
-          <a:xfrm>
-            <a:off x="3884613" y="0"/>
-            <a:ext cx="2971800" cy="458788"/>
-          </a:xfrm>
-          <a:prstGeom prst="rect">
-            <a:avLst/>
-          </a:prstGeom>
-        </p:spPr>
-        <p:txBody>
-          <a:bodyPr vert="horz" lIns="91440" tIns="45720" rIns="91440" bIns="45720" rtlCol="0"/>
-          <a:lstStyle>
-            <a:lvl1pPr algn="r">
-              <a:defRPr sz="1200"/>
-            </a:lvl1pPr>
-          </a:lstStyle>
-          <a:p>
-            <a:fld id="{5282F153-3F37-0F45-9E97-73ACFA13230C}" type="datetimeFigureOut">
-              <a:rPr lang="en-US"/>
-              <a:t>7/23/19</a:t>
-            </a:fld>
-            <a:endParaRPr lang="en-US"/>
-          </a:p>
-        </p:txBody>
-      </p:sp>
-      <p:sp>
-        <p:nvSpPr>
-          <p:cNvPr id="4" name="Slide Image Placeholder 3"/>
-          <p:cNvSpPr>
-            <a:spLocks noGrp="1" noRot="1" noChangeAspect="1"/>
-          </p:cNvSpPr>
-          <p:nvPr>
-            <p:ph type="sldImg" idx="2"/>
-          </p:nvPr>
-        </p:nvSpPr>
-        <p:spPr>
-          <a:xfrm>
-            <a:off x="685800" y="1143000"/>
-            <a:ext cx="5486400" cy="3086100"/>
-          </a:xfrm>
-          <a:prstGeom prst="rect">
-            <a:avLst/>
-          </a:prstGeom>
-          <a:noFill/>
-          <a:ln w="12700">
-            <a:solidFill>
-              <a:prstClr val="black"/>
-            </a:solidFill>
-          </a:ln>
-        </p:spPr>
-        <p:txBody>
-          <a:bodyPr vert="horz" lIns="91440" tIns="45720" rIns="91440" bIns="45720" rtlCol="0" anchor="ctr"/>
-          <a:lstStyle/>
-          <a:p>
-            <a:endParaRPr lang="en-US"/>
-          </a:p>
-        </p:txBody>
-      </p:sp>
-      <p:sp>
-        <p:nvSpPr>
-          <p:cNvPr id="5" name="Notes Placeholder 4"/>
-          <p:cNvSpPr>
-            <a:spLocks noGrp="1"/>
-          </p:cNvSpPr>
-          <p:nvPr>
-            <p:ph type="body" sz="quarter" idx="3"/>
-          </p:nvPr>
-        </p:nvSpPr>
-        <p:spPr>
-          <a:xfrm>
-            <a:off x="685800" y="4400550"/>
-            <a:ext cx="5486400" cy="3600450"/>
-          </a:xfrm>
-          <a:prstGeom prst="rect">
-            <a:avLst/>
-          </a:prstGeom>
-        </p:spPr>
-        <p:txBody>
-          <a:bodyPr vert="horz" lIns="91440" tIns="45720" rIns="91440" bIns="45720" rtlCol="0"/>
-          <a:lstStyle/>
-          <a:p>
-            <a:pPr lvl="0"/>
-            <a:r>
-              <a:rPr lang="en-US"/>
-              <a:t>Click to edit Master text styles</a:t>
-            </a:r>
-          </a:p>
-          <a:p>
-            <a:pPr lvl="1"/>
-            <a:r>
-              <a:rPr lang="en-US"/>
-              <a:t>Second level</a:t>
-            </a:r>
-          </a:p>
-          <a:p>
-            <a:pPr lvl="2"/>
-            <a:r>
-              <a:rPr lang="en-US"/>
-              <a:t>Third level</a:t>
-            </a:r>
-          </a:p>
-          <a:p>
-            <a:pPr lvl="3"/>
-            <a:r>
-              <a:rPr lang="en-US"/>
-              <a:t>Fourth level</a:t>
-            </a:r>
-          </a:p>
-          <a:p>
-            <a:pPr lvl="4"/>
-            <a:r>
-              <a:rPr lang="en-US"/>
-              <a:t>Fifth level</a:t>
-            </a:r>
-          </a:p>
-        </p:txBody>
-      </p:sp>
-      <p:sp>
-        <p:nvSpPr>
-          <p:cNvPr id="6" name="Footer Placeholder 5"/>
-          <p:cNvSpPr>
-            <a:spLocks noGrp="1"/>
-          </p:cNvSpPr>
-          <p:nvPr>
-            <p:ph type="ftr" sz="quarter" idx="4"/>
-          </p:nvPr>
-        </p:nvSpPr>
-        <p:spPr>
-          <a:xfrm>
-            <a:off x="0" y="8685213"/>
-            <a:ext cx="2971800" cy="458787"/>
-          </a:xfrm>
-          <a:prstGeom prst="rect">
-            <a:avLst/>
-          </a:prstGeom>
-        </p:spPr>
-        <p:txBody>
-          <a:bodyPr vert="horz" lIns="91440" tIns="45720" rIns="91440" bIns="45720" rtlCol="0" anchor="b"/>
-          <a:lstStyle>
-            <a:lvl1pPr algn="l">
-              <a:defRPr sz="1200"/>
-            </a:lvl1pPr>
-          </a:lstStyle>
-          <a:p>
-            <a:endParaRPr lang="en-US"/>
-          </a:p>
-        </p:txBody>
-      </p:sp>
-      <p:sp>
-        <p:nvSpPr>
-          <p:cNvPr id="7" name="Slide Number Placeholder 6"/>
-          <p:cNvSpPr>
-            <a:spLocks noGrp="1"/>
-          </p:cNvSpPr>
-          <p:nvPr>
-            <p:ph type="sldNum" sz="quarter" idx="5"/>
-          </p:nvPr>
-        </p:nvSpPr>
-        <p:spPr>
-          <a:xfrm>
-            <a:off x="3884613" y="8685213"/>
-            <a:ext cx="2971800" cy="458787"/>
-          </a:xfrm>
-          <a:prstGeom prst="rect">
-            <a:avLst/>
-          </a:prstGeom>
-        </p:spPr>
-        <p:txBody>
-          <a:bodyPr vert="horz" lIns="91440" tIns="45720" rIns="91440" bIns="45720" rtlCol="0" anchor="b"/>
-          <a:lstStyle>
-            <a:lvl1pPr algn="r">
-              <a:defRPr sz="1200"/>
-            </a:lvl1pPr>
-          </a:lstStyle>
-          <a:p>
-            <a:fld id="{CE5E9CC1-C706-0F49-92D6-E571CC5EEA8F}" type="slidenum">
-              <a:rPr lang="en-US"/>
-              <a:t>‹#›</a:t>
-            </a:fld>
-            <a:endParaRPr lang="en-US"/>
-          </a:p>
-        </p:txBody>
-      </p:sp>
     </p:spTree>
     <p:extLst>
       <p:ext uri="{BB962C8B-B14F-4D97-AF65-F5344CB8AC3E}">
-        <p14:creationId xmlns:p14="http://schemas.microsoft.com/office/powerpoint/2010/main" val="1024086991"/>
+        <p14:creationId xmlns:p14="http://schemas.microsoft.com/office/powerpoint/2010/main" val="832306869"/>
       </p:ext>
     </p:extLst>
   </p:cSld>
@@ -518,10 +299,6 @@
           <a:bodyPr/>
           <a:lstStyle/>
           <a:p>
-            <a:r>
-              <a:rPr lang="en-US" dirty="0"/>
-              <a:t/>
-            </a:r>
             <a:endParaRPr lang="en-US" dirty="0"/>
           </a:p>
         </p:txBody>
@@ -606,10 +383,6 @@
           <a:bodyPr/>
           <a:lstStyle/>
           <a:p>
-            <a:r>
-              <a:rPr lang="en-US" dirty="0"/>
-              <a:t/>
-            </a:r>
             <a:endParaRPr lang="en-US" dirty="0"/>
           </a:p>
         </p:txBody>
@@ -694,10 +467,6 @@
           <a:bodyPr/>
           <a:lstStyle/>
           <a:p>
-            <a:r>
-              <a:rPr lang="en-US" dirty="0"/>
-              <a:t/>
-            </a:r>
             <a:endParaRPr lang="en-US" dirty="0"/>
           </a:p>
         </p:txBody>
@@ -782,10 +551,6 @@
           <a:bodyPr/>
           <a:lstStyle/>
           <a:p>
-            <a:r>
-              <a:rPr lang="en-US" dirty="0"/>
-              <a:t/>
-            </a:r>
             <a:endParaRPr lang="en-US" dirty="0"/>
           </a:p>
         </p:txBody>
@@ -870,10 +635,6 @@
           <a:bodyPr/>
           <a:lstStyle/>
           <a:p>
-            <a:r>
-              <a:rPr lang="en-US" dirty="0"/>
-              <a:t/>
-            </a:r>
             <a:endParaRPr lang="en-US" dirty="0"/>
           </a:p>
         </p:txBody>
@@ -958,10 +719,6 @@
           <a:bodyPr/>
           <a:lstStyle/>
           <a:p>
-            <a:r>
-              <a:rPr lang="en-US" dirty="0"/>
-              <a:t/>
-            </a:r>
             <a:endParaRPr lang="en-US" dirty="0"/>
           </a:p>
         </p:txBody>
@@ -1046,10 +803,6 @@
           <a:bodyPr/>
           <a:lstStyle/>
           <a:p>
-            <a:r>
-              <a:rPr lang="en-US" dirty="0"/>
-              <a:t/>
-            </a:r>
             <a:endParaRPr lang="en-US" dirty="0"/>
           </a:p>
         </p:txBody>
@@ -1134,10 +887,6 @@
           <a:bodyPr/>
           <a:lstStyle/>
           <a:p>
-            <a:r>
-              <a:rPr lang="en-US" dirty="0"/>
-              <a:t/>
-            </a:r>
             <a:endParaRPr lang="en-US" dirty="0"/>
           </a:p>
         </p:txBody>
@@ -1222,10 +971,6 @@
           <a:bodyPr/>
           <a:lstStyle/>
           <a:p>
-            <a:r>
-              <a:rPr lang="en-US" dirty="0"/>
-              <a:t/>
-            </a:r>
             <a:endParaRPr lang="en-US" dirty="0"/>
           </a:p>
         </p:txBody>
@@ -1310,10 +1055,6 @@
           <a:bodyPr/>
           <a:lstStyle/>
           <a:p>
-            <a:r>
-              <a:rPr lang="en-US" dirty="0"/>
-              <a:t/>
-            </a:r>
             <a:endParaRPr lang="en-US" dirty="0"/>
           </a:p>
         </p:txBody>
@@ -1398,10 +1139,6 @@
           <a:bodyPr/>
           <a:lstStyle/>
           <a:p>
-            <a:r>
-              <a:rPr lang="en-US" dirty="0"/>
-              <a:t/>
-            </a:r>
             <a:endParaRPr lang="en-US" dirty="0"/>
           </a:p>
         </p:txBody>
@@ -1486,10 +1223,6 @@
           <a:bodyPr/>
           <a:lstStyle/>
           <a:p>
-            <a:r>
-              <a:rPr lang="en-US" dirty="0"/>
-              <a:t/>
-            </a:r>
             <a:endParaRPr lang="en-US" dirty="0"/>
           </a:p>
         </p:txBody>
@@ -1574,10 +1307,6 @@
           <a:bodyPr/>
           <a:lstStyle/>
           <a:p>
-            <a:r>
-              <a:rPr lang="en-US" dirty="0"/>
-              <a:t/>
-            </a:r>
             <a:endParaRPr lang="en-US" dirty="0"/>
           </a:p>
         </p:txBody>
@@ -1662,10 +1391,6 @@
           <a:bodyPr/>
           <a:lstStyle/>
           <a:p>
-            <a:r>
-              <a:rPr lang="en-US" dirty="0"/>
-              <a:t/>
-            </a:r>
             <a:endParaRPr lang="en-US" dirty="0"/>
           </a:p>
         </p:txBody>
@@ -1750,10 +1475,6 @@
           <a:bodyPr/>
           <a:lstStyle/>
           <a:p>
-            <a:r>
-              <a:rPr lang="en-US" dirty="0"/>
-              <a:t/>
-            </a:r>
             <a:endParaRPr lang="en-US" dirty="0"/>
           </a:p>
         </p:txBody>
@@ -1838,10 +1559,6 @@
           <a:bodyPr/>
           <a:lstStyle/>
           <a:p>
-            <a:r>
-              <a:rPr lang="en-US" dirty="0"/>
-              <a:t/>
-            </a:r>
             <a:endParaRPr lang="en-US" dirty="0"/>
           </a:p>
         </p:txBody>
@@ -1926,10 +1643,6 @@
           <a:bodyPr/>
           <a:lstStyle/>
           <a:p>
-            <a:r>
-              <a:rPr lang="en-US" dirty="0"/>
-              <a:t/>
-            </a:r>
             <a:endParaRPr lang="en-US" dirty="0"/>
           </a:p>
         </p:txBody>
@@ -2014,10 +1727,6 @@
           <a:bodyPr/>
           <a:lstStyle/>
           <a:p>
-            <a:r>
-              <a:rPr lang="en-US" dirty="0"/>
-              <a:t/>
-            </a:r>
             <a:endParaRPr lang="en-US" dirty="0"/>
           </a:p>
         </p:txBody>
@@ -2102,10 +1811,6 @@
           <a:bodyPr/>
           <a:lstStyle/>
           <a:p>
-            <a:r>
-              <a:rPr lang="en-US" dirty="0"/>
-              <a:t/>
-            </a:r>
             <a:endParaRPr lang="en-US" dirty="0"/>
           </a:p>
         </p:txBody>
@@ -2179,6 +1884,11 @@
 <file path=ppt/slideMasters/slideMaster1.xml><?xml version="1.0" encoding="utf-8"?>
 <p:sldMaster xmlns:a="http://schemas.openxmlformats.org/drawingml/2006/main" xmlns:r="http://schemas.openxmlformats.org/officeDocument/2006/relationships" xmlns:p="http://schemas.openxmlformats.org/presentationml/2006/main">
   <p:cSld>
+    <p:bg>
+      <p:bgRef idx="1001">
+        <a:schemeClr val="bg1"/>
+      </p:bgRef>
+    </p:bg>
     <p:spTree>
       <p:nvGrpSpPr>
         <p:cNvPr id="1" name=""/>
@@ -2461,6 +2171,7 @@
         <a:solidFill>
           <a:srgbClr val="FF4438"/>
         </a:solidFill>
+        <a:effectLst/>
       </p:bgPr>
     </p:bg>
     <p:spTree>
@@ -2498,7 +2209,7 @@
           <a:bodyPr wrap="square" lIns="0" tIns="0" rIns="0" bIns="0" rtlCol="0" anchor="ctr"/>
           <a:lstStyle/>
           <a:p>
-            <a:pPr indent="0" marL="0">
+            <a:pPr marL="0" indent="0">
               <a:buNone/>
             </a:pPr>
             <a:r>
@@ -2537,7 +2248,7 @@
           <a:bodyPr wrap="square" lIns="0" tIns="0" rIns="0" bIns="0" rtlCol="0" anchor="ctr"/>
           <a:lstStyle/>
           <a:p>
-            <a:pPr indent="0" marL="0">
+            <a:pPr marL="0" indent="0">
               <a:buNone/>
             </a:pPr>
             <a:r>
@@ -2576,7 +2287,7 @@
           <a:bodyPr wrap="square" lIns="0" tIns="0" rIns="0" bIns="0" rtlCol="0" anchor="ctr"/>
           <a:lstStyle/>
           <a:p>
-            <a:pPr indent="0" marL="0">
+            <a:pPr marL="0" indent="0">
               <a:buNone/>
             </a:pPr>
             <a:r>
@@ -2615,7 +2326,7 @@
           <a:bodyPr wrap="square" lIns="0" tIns="0" rIns="0" bIns="0" rtlCol="0" anchor="ctr"/>
           <a:lstStyle/>
           <a:p>
-            <a:pPr indent="0" marL="0">
+            <a:pPr marL="0" indent="0">
               <a:buNone/>
             </a:pPr>
             <a:r>
@@ -2654,7 +2365,7 @@
           <a:bodyPr wrap="square" lIns="0" tIns="0" rIns="0" bIns="0" rtlCol="0" anchor="ctr"/>
           <a:lstStyle/>
           <a:p>
-            <a:pPr indent="0" marL="0">
+            <a:pPr marL="0" indent="0">
               <a:buNone/>
             </a:pPr>
             <a:r>
@@ -2690,6 +2401,7 @@
         <a:solidFill>
           <a:srgbClr val="FFFFFF"/>
         </a:solidFill>
+        <a:effectLst/>
       </p:bgPr>
     </p:bg>
     <p:spTree>
@@ -2727,7 +2439,7 @@
           <a:bodyPr wrap="square" lIns="0" tIns="0" rIns="0" bIns="0" rtlCol="0" anchor="ctr"/>
           <a:lstStyle/>
           <a:p>
-            <a:pPr indent="0" marL="0">
+            <a:pPr marL="0" indent="0">
               <a:buNone/>
             </a:pPr>
             <a:r>
@@ -2766,7 +2478,7 @@
           <a:bodyPr wrap="square" lIns="0" tIns="0" rIns="0" bIns="0" rtlCol="0" anchor="ctr"/>
           <a:lstStyle/>
           <a:p>
-            <a:pPr indent="0" marL="0">
+            <a:pPr marL="0" indent="0">
               <a:buNone/>
             </a:pPr>
             <a:r>
@@ -2881,7 +2593,7 @@
           <a:bodyPr wrap="square" lIns="0" tIns="0" rIns="0" bIns="0" rtlCol="0" anchor="ctr"/>
           <a:lstStyle/>
           <a:p>
-            <a:pPr indent="0" marL="0">
+            <a:pPr marL="0" indent="0">
               <a:buNone/>
             </a:pPr>
             <a:r>
@@ -2920,7 +2632,7 @@
           <a:bodyPr wrap="square" lIns="0" tIns="0" rIns="0" bIns="0" rtlCol="0" anchor="ctr"/>
           <a:lstStyle/>
           <a:p>
-            <a:pPr indent="0" marL="0">
+            <a:pPr marL="0" indent="0">
               <a:buNone/>
             </a:pPr>
             <a:r>
@@ -2959,7 +2671,7 @@
           <a:bodyPr wrap="square" lIns="0" tIns="0" rIns="0" bIns="0" rtlCol="0" anchor="ctr"/>
           <a:lstStyle/>
           <a:p>
-            <a:pPr indent="0" marL="0">
+            <a:pPr marL="0" indent="0">
               <a:buNone/>
             </a:pPr>
             <a:r>
@@ -2998,7 +2710,7 @@
           <a:bodyPr wrap="square" lIns="0" tIns="0" rIns="0" bIns="0" rtlCol="0" anchor="ctr"/>
           <a:lstStyle/>
           <a:p>
-            <a:pPr indent="0" marL="0">
+            <a:pPr marL="0" indent="0">
               <a:buNone/>
             </a:pPr>
             <a:r>
@@ -3037,7 +2749,7 @@
           <a:bodyPr wrap="square" lIns="0" tIns="0" rIns="0" bIns="0" rtlCol="0" anchor="ctr"/>
           <a:lstStyle/>
           <a:p>
-            <a:pPr algn="r" indent="0" marL="0">
+            <a:pPr marL="0" indent="0" algn="r">
               <a:buNone/>
             </a:pPr>
             <a:r>
@@ -3071,6 +2783,7 @@
         <a:solidFill>
           <a:srgbClr val="091A23"/>
         </a:solidFill>
+        <a:effectLst/>
       </p:bgPr>
     </p:bg>
     <p:spTree>
@@ -3111,6 +2824,13 @@
             <a:prstDash val="solid"/>
           </a:ln>
         </p:spPr>
+        <p:txBody>
+          <a:bodyPr/>
+          <a:lstStyle/>
+          <a:p>
+            <a:endParaRPr lang="en-US"/>
+          </a:p>
+        </p:txBody>
       </p:sp>
       <p:sp>
         <p:nvSpPr>
@@ -3133,11 +2853,11 @@
           <a:bodyPr wrap="square" lIns="0" tIns="0" rIns="0" bIns="0" rtlCol="0" anchor="ctr"/>
           <a:lstStyle/>
           <a:p>
-            <a:pPr indent="0" marL="0">
-              <a:buNone/>
-            </a:pPr>
-            <a:r>
-              <a:rPr lang="en-US" sz="1000" b="1" spc="200" kern="0" dirty="0">
+            <a:pPr marL="0" indent="0">
+              <a:buNone/>
+            </a:pPr>
+            <a:r>
+              <a:rPr lang="en-US" sz="1000" b="1" kern="0" spc="200" dirty="0">
                 <a:solidFill>
                   <a:srgbClr val="FFFFFF"/>
                 </a:solidFill>
@@ -3172,7 +2892,7 @@
           <a:bodyPr wrap="square" lIns="0" tIns="0" rIns="0" bIns="0" rtlCol="0" anchor="ctr"/>
           <a:lstStyle/>
           <a:p>
-            <a:pPr indent="0" marL="0">
+            <a:pPr marL="0" indent="0">
               <a:buNone/>
             </a:pPr>
             <a:r>
@@ -3211,7 +2931,7 @@
           <a:bodyPr wrap="square" lIns="0" tIns="0" rIns="0" bIns="0" rtlCol="0" anchor="ctr"/>
           <a:lstStyle/>
           <a:p>
-            <a:pPr indent="0" marL="0">
+            <a:pPr marL="0" indent="0">
               <a:buNone/>
             </a:pPr>
             <a:r>
@@ -3250,7 +2970,7 @@
           <a:bodyPr wrap="square" lIns="0" tIns="0" rIns="0" bIns="0" rtlCol="0" anchor="ctr"/>
           <a:lstStyle/>
           <a:p>
-            <a:pPr indent="0" marL="0">
+            <a:pPr marL="0" indent="0">
               <a:buNone/>
             </a:pPr>
             <a:r>
@@ -3284,6 +3004,7 @@
         <a:solidFill>
           <a:srgbClr val="FFFFFF"/>
         </a:solidFill>
+        <a:effectLst/>
       </p:bgPr>
     </p:bg>
     <p:spTree>
@@ -3321,7 +3042,7 @@
           <a:bodyPr wrap="square" lIns="0" tIns="0" rIns="0" bIns="0" rtlCol="0" anchor="ctr"/>
           <a:lstStyle/>
           <a:p>
-            <a:pPr indent="0" marL="0">
+            <a:pPr marL="0" indent="0">
               <a:buNone/>
             </a:pPr>
             <a:r>
@@ -3360,7 +3081,7 @@
           <a:bodyPr wrap="square" lIns="0" tIns="0" rIns="0" bIns="0" rtlCol="0" anchor="ctr"/>
           <a:lstStyle/>
           <a:p>
-            <a:pPr indent="0" marL="0">
+            <a:pPr marL="0" indent="0">
               <a:buNone/>
             </a:pPr>
             <a:r>
@@ -3399,7 +3120,7 @@
           <a:bodyPr wrap="square" lIns="0" tIns="0" rIns="0" bIns="0" rtlCol="0" anchor="ctr"/>
           <a:lstStyle/>
           <a:p>
-            <a:pPr indent="0" marL="0">
+            <a:pPr marL="0" indent="0">
               <a:buNone/>
             </a:pPr>
             <a:r>
@@ -3438,7 +3159,7 @@
           <a:bodyPr wrap="square" lIns="0" tIns="0" rIns="0" bIns="0" rtlCol="0" anchor="ctr"/>
           <a:lstStyle/>
           <a:p>
-            <a:pPr indent="0" marL="0">
+            <a:pPr marL="0" indent="0">
               <a:buNone/>
             </a:pPr>
             <a:r>
@@ -3477,7 +3198,7 @@
           <a:bodyPr wrap="square" lIns="0" tIns="0" rIns="0" bIns="0" rtlCol="0" anchor="ctr"/>
           <a:lstStyle/>
           <a:p>
-            <a:pPr indent="0" marL="0">
+            <a:pPr marL="0" indent="0">
               <a:buNone/>
             </a:pPr>
             <a:r>
@@ -3516,7 +3237,7 @@
           <a:bodyPr wrap="square" lIns="0" tIns="0" rIns="0" bIns="0" rtlCol="0" anchor="ctr"/>
           <a:lstStyle/>
           <a:p>
-            <a:pPr indent="0" marL="0">
+            <a:pPr marL="0" indent="0">
               <a:buNone/>
             </a:pPr>
             <a:r>
@@ -3555,7 +3276,7 @@
           <a:bodyPr wrap="square" lIns="0" tIns="0" rIns="0" bIns="0" rtlCol="0" anchor="ctr"/>
           <a:lstStyle/>
           <a:p>
-            <a:pPr algn="r" indent="0" marL="0">
+            <a:pPr marL="0" indent="0" algn="r">
               <a:buNone/>
             </a:pPr>
             <a:r>
@@ -3589,6 +3310,7 @@
         <a:solidFill>
           <a:srgbClr val="091A23"/>
         </a:solidFill>
+        <a:effectLst/>
       </p:bgPr>
     </p:bg>
     <p:spTree>
@@ -3626,7 +3348,7 @@
           <a:bodyPr wrap="square" lIns="0" tIns="0" rIns="0" bIns="0" rtlCol="0" anchor="ctr"/>
           <a:lstStyle/>
           <a:p>
-            <a:pPr indent="0" marL="0">
+            <a:pPr marL="0" indent="0">
               <a:buNone/>
             </a:pPr>
             <a:r>
@@ -3665,7 +3387,7 @@
           <a:bodyPr wrap="square" lIns="0" tIns="0" rIns="0" bIns="0" rtlCol="0" anchor="ctr"/>
           <a:lstStyle/>
           <a:p>
-            <a:pPr indent="0" marL="0">
+            <a:pPr marL="0" indent="0">
               <a:buNone/>
             </a:pPr>
             <a:r>
@@ -3707,6 +3429,13 @@
             <a:prstDash val="solid"/>
           </a:ln>
         </p:spPr>
+        <p:txBody>
+          <a:bodyPr/>
+          <a:lstStyle/>
+          <a:p>
+            <a:endParaRPr lang="en-US"/>
+          </a:p>
+        </p:txBody>
       </p:sp>
       <p:sp>
         <p:nvSpPr>
@@ -3729,7 +3458,7 @@
           <a:bodyPr wrap="square" lIns="0" tIns="0" rIns="0" bIns="0" rtlCol="0" anchor="t"/>
           <a:lstStyle/>
           <a:p>
-            <a:pPr algn="l" indent="0" marL="0">
+            <a:pPr marL="0" indent="0" algn="l">
               <a:buNone/>
             </a:pPr>
             <a:r>
@@ -3746,7 +3475,7 @@
             <a:endParaRPr lang="en-US" sz="1150" dirty="0"/>
           </a:p>
           <a:p>
-            <a:pPr algn="l" indent="0" marL="0">
+            <a:pPr marL="0" indent="0" algn="l">
               <a:buNone/>
             </a:pPr>
             <a:r>
@@ -3763,13 +3492,13 @@
             <a:endParaRPr lang="en-US" sz="1150" dirty="0"/>
           </a:p>
           <a:p>
-            <a:pPr algn="l" indent="0" marL="0">
+            <a:pPr marL="0" indent="0" algn="l">
               <a:buNone/>
             </a:pPr>
             <a:endParaRPr lang="en-US" sz="1150" dirty="0"/>
           </a:p>
           <a:p>
-            <a:pPr algn="l" indent="0" marL="0">
+            <a:pPr marL="0" indent="0" algn="l">
               <a:buNone/>
             </a:pPr>
             <a:r>
@@ -3786,7 +3515,7 @@
             <a:endParaRPr lang="en-US" sz="1150" dirty="0"/>
           </a:p>
           <a:p>
-            <a:pPr algn="l" indent="0" marL="0">
+            <a:pPr marL="0" indent="0" algn="l">
               <a:buNone/>
             </a:pPr>
             <a:r>
@@ -3803,7 +3532,7 @@
             <a:endParaRPr lang="en-US" sz="1150" dirty="0"/>
           </a:p>
           <a:p>
-            <a:pPr algn="l" indent="0" marL="0">
+            <a:pPr marL="0" indent="0" algn="l">
               <a:buNone/>
             </a:pPr>
             <a:r>
@@ -3820,13 +3549,13 @@
             <a:endParaRPr lang="en-US" sz="1150" dirty="0"/>
           </a:p>
           <a:p>
-            <a:pPr algn="l" indent="0" marL="0">
+            <a:pPr marL="0" indent="0" algn="l">
               <a:buNone/>
             </a:pPr>
             <a:endParaRPr lang="en-US" sz="1150" dirty="0"/>
           </a:p>
           <a:p>
-            <a:pPr algn="l" indent="0" marL="0">
+            <a:pPr marL="0" indent="0" algn="l">
               <a:buNone/>
             </a:pPr>
             <a:r>
@@ -3843,7 +3572,7 @@
             <a:endParaRPr lang="en-US" sz="1150" dirty="0"/>
           </a:p>
           <a:p>
-            <a:pPr algn="l" indent="0" marL="0">
+            <a:pPr marL="0" indent="0" algn="l">
               <a:buNone/>
             </a:pPr>
             <a:r>
@@ -3860,7 +3589,7 @@
             <a:endParaRPr lang="en-US" sz="1150" dirty="0"/>
           </a:p>
           <a:p>
-            <a:pPr algn="l" indent="0" marL="0">
+            <a:pPr marL="0" indent="0" algn="l">
               <a:buNone/>
             </a:pPr>
             <a:r>
@@ -3899,7 +3628,7 @@
           <a:bodyPr wrap="square" lIns="0" tIns="0" rIns="0" bIns="0" rtlCol="0" anchor="ctr"/>
           <a:lstStyle/>
           <a:p>
-            <a:pPr indent="0" marL="0">
+            <a:pPr marL="0" indent="0">
               <a:buNone/>
             </a:pPr>
             <a:r>
@@ -3938,7 +3667,7 @@
           <a:bodyPr wrap="square" lIns="0" tIns="0" rIns="0" bIns="0" rtlCol="0" anchor="ctr"/>
           <a:lstStyle/>
           <a:p>
-            <a:pPr indent="0" marL="0">
+            <a:pPr marL="0" indent="0">
               <a:buNone/>
             </a:pPr>
             <a:r>
@@ -3977,7 +3706,7 @@
           <a:bodyPr wrap="square" lIns="0" tIns="0" rIns="0" bIns="0" rtlCol="0" anchor="ctr"/>
           <a:lstStyle/>
           <a:p>
-            <a:pPr algn="r" indent="0" marL="0">
+            <a:pPr marL="0" indent="0" algn="r">
               <a:buNone/>
             </a:pPr>
             <a:r>
@@ -4011,6 +3740,7 @@
         <a:solidFill>
           <a:srgbClr val="091A23"/>
         </a:solidFill>
+        <a:effectLst/>
       </p:bgPr>
     </p:bg>
     <p:spTree>
@@ -4048,7 +3778,7 @@
           <a:bodyPr wrap="square" lIns="0" tIns="0" rIns="0" bIns="0" rtlCol="0" anchor="ctr"/>
           <a:lstStyle/>
           <a:p>
-            <a:pPr indent="0" marL="0">
+            <a:pPr marL="0" indent="0">
               <a:buNone/>
             </a:pPr>
             <a:r>
@@ -4087,7 +3817,7 @@
           <a:bodyPr wrap="square" lIns="0" tIns="0" rIns="0" bIns="0" rtlCol="0" anchor="ctr"/>
           <a:lstStyle/>
           <a:p>
-            <a:pPr indent="0" marL="0">
+            <a:pPr marL="0" indent="0">
               <a:buNone/>
             </a:pPr>
             <a:r>
@@ -4129,6 +3859,13 @@
             <a:prstDash val="solid"/>
           </a:ln>
         </p:spPr>
+        <p:txBody>
+          <a:bodyPr/>
+          <a:lstStyle/>
+          <a:p>
+            <a:endParaRPr lang="en-US"/>
+          </a:p>
+        </p:txBody>
       </p:sp>
       <p:sp>
         <p:nvSpPr>
@@ -4151,7 +3888,7 @@
           <a:bodyPr wrap="square" lIns="0" tIns="0" rIns="0" bIns="0" rtlCol="0" anchor="t"/>
           <a:lstStyle/>
           <a:p>
-            <a:pPr algn="l" indent="0" marL="0">
+            <a:pPr marL="0" indent="0" algn="l">
               <a:buNone/>
             </a:pPr>
             <a:r>
@@ -4168,7 +3905,7 @@
             <a:endParaRPr lang="en-US" sz="1150" dirty="0"/>
           </a:p>
           <a:p>
-            <a:pPr algn="l" indent="0" marL="0">
+            <a:pPr marL="0" indent="0" algn="l">
               <a:buNone/>
             </a:pPr>
             <a:r>
@@ -4185,7 +3922,7 @@
             <a:endParaRPr lang="en-US" sz="1150" dirty="0"/>
           </a:p>
           <a:p>
-            <a:pPr algn="l" indent="0" marL="0">
+            <a:pPr marL="0" indent="0" algn="l">
               <a:buNone/>
             </a:pPr>
             <a:r>
@@ -4202,13 +3939,13 @@
             <a:endParaRPr lang="en-US" sz="1150" dirty="0"/>
           </a:p>
           <a:p>
-            <a:pPr algn="l" indent="0" marL="0">
+            <a:pPr marL="0" indent="0" algn="l">
               <a:buNone/>
             </a:pPr>
             <a:endParaRPr lang="en-US" sz="1150" dirty="0"/>
           </a:p>
           <a:p>
-            <a:pPr algn="l" indent="0" marL="0">
+            <a:pPr marL="0" indent="0" algn="l">
               <a:buNone/>
             </a:pPr>
             <a:r>
@@ -4225,7 +3962,7 @@
             <a:endParaRPr lang="en-US" sz="1150" dirty="0"/>
           </a:p>
           <a:p>
-            <a:pPr algn="l" indent="0" marL="0">
+            <a:pPr marL="0" indent="0" algn="l">
               <a:buNone/>
             </a:pPr>
             <a:r>
@@ -4242,13 +3979,13 @@
             <a:endParaRPr lang="en-US" sz="1150" dirty="0"/>
           </a:p>
           <a:p>
-            <a:pPr algn="l" indent="0" marL="0">
+            <a:pPr marL="0" indent="0" algn="l">
               <a:buNone/>
             </a:pPr>
             <a:endParaRPr lang="en-US" sz="1150" dirty="0"/>
           </a:p>
           <a:p>
-            <a:pPr algn="l" indent="0" marL="0">
+            <a:pPr marL="0" indent="0" algn="l">
               <a:buNone/>
             </a:pPr>
             <a:r>
@@ -4265,7 +4002,7 @@
             <a:endParaRPr lang="en-US" sz="1150" dirty="0"/>
           </a:p>
           <a:p>
-            <a:pPr algn="l" indent="0" marL="0">
+            <a:pPr marL="0" indent="0" algn="l">
               <a:buNone/>
             </a:pPr>
             <a:r>
@@ -4282,7 +4019,7 @@
             <a:endParaRPr lang="en-US" sz="1150" dirty="0"/>
           </a:p>
           <a:p>
-            <a:pPr algn="l" indent="0" marL="0">
+            <a:pPr marL="0" indent="0" algn="l">
               <a:buNone/>
             </a:pPr>
             <a:r>
@@ -4299,7 +4036,7 @@
             <a:endParaRPr lang="en-US" sz="1150" dirty="0"/>
           </a:p>
           <a:p>
-            <a:pPr algn="l" indent="0" marL="0">
+            <a:pPr marL="0" indent="0" algn="l">
               <a:buNone/>
             </a:pPr>
             <a:r>
@@ -4316,7 +4053,7 @@
             <a:endParaRPr lang="en-US" sz="1150" dirty="0"/>
           </a:p>
           <a:p>
-            <a:pPr algn="l" indent="0" marL="0">
+            <a:pPr marL="0" indent="0" algn="l">
               <a:buNone/>
             </a:pPr>
             <a:r>
@@ -4355,7 +4092,7 @@
           <a:bodyPr wrap="square" lIns="0" tIns="0" rIns="0" bIns="0" rtlCol="0" anchor="ctr"/>
           <a:lstStyle/>
           <a:p>
-            <a:pPr indent="0" marL="0">
+            <a:pPr marL="0" indent="0">
               <a:buNone/>
             </a:pPr>
             <a:r>
@@ -4394,7 +4131,7 @@
           <a:bodyPr wrap="square" lIns="0" tIns="0" rIns="0" bIns="0" rtlCol="0" anchor="ctr"/>
           <a:lstStyle/>
           <a:p>
-            <a:pPr indent="0" marL="0">
+            <a:pPr marL="0" indent="0">
               <a:buNone/>
             </a:pPr>
             <a:r>
@@ -4433,7 +4170,7 @@
           <a:bodyPr wrap="square" lIns="0" tIns="0" rIns="0" bIns="0" rtlCol="0" anchor="ctr"/>
           <a:lstStyle/>
           <a:p>
-            <a:pPr algn="r" indent="0" marL="0">
+            <a:pPr marL="0" indent="0" algn="r">
               <a:buNone/>
             </a:pPr>
             <a:r>
@@ -4467,6 +4204,7 @@
         <a:solidFill>
           <a:srgbClr val="FFFFFF"/>
         </a:solidFill>
+        <a:effectLst/>
       </p:bgPr>
     </p:bg>
     <p:spTree>
@@ -4504,7 +4242,7 @@
           <a:bodyPr wrap="square" lIns="0" tIns="0" rIns="0" bIns="0" rtlCol="0" anchor="ctr"/>
           <a:lstStyle/>
           <a:p>
-            <a:pPr indent="0" marL="0">
+            <a:pPr marL="0" indent="0">
               <a:buNone/>
             </a:pPr>
             <a:r>
@@ -4543,7 +4281,7 @@
           <a:bodyPr wrap="square" lIns="0" tIns="0" rIns="0" bIns="0" rtlCol="0" anchor="ctr"/>
           <a:lstStyle/>
           <a:p>
-            <a:pPr indent="0" marL="0">
+            <a:pPr marL="0" indent="0">
               <a:buNone/>
             </a:pPr>
             <a:r>
@@ -4658,7 +4396,7 @@
           <a:bodyPr wrap="square" lIns="0" tIns="0" rIns="0" bIns="0" rtlCol="0" anchor="ctr"/>
           <a:lstStyle/>
           <a:p>
-            <a:pPr indent="0" marL="0">
+            <a:pPr marL="0" indent="0">
               <a:buNone/>
             </a:pPr>
             <a:r>
@@ -4697,7 +4435,7 @@
           <a:bodyPr wrap="square" lIns="0" tIns="0" rIns="0" bIns="0" rtlCol="0" anchor="ctr"/>
           <a:lstStyle/>
           <a:p>
-            <a:pPr indent="0" marL="0">
+            <a:pPr marL="0" indent="0">
               <a:buNone/>
             </a:pPr>
             <a:r>
@@ -4736,7 +4474,7 @@
           <a:bodyPr wrap="square" lIns="0" tIns="0" rIns="0" bIns="0" rtlCol="0" anchor="ctr"/>
           <a:lstStyle/>
           <a:p>
-            <a:pPr algn="r" indent="0" marL="0">
+            <a:pPr marL="0" indent="0" algn="r">
               <a:buNone/>
             </a:pPr>
             <a:r>
@@ -4770,6 +4508,7 @@
         <a:solidFill>
           <a:srgbClr val="091A23"/>
         </a:solidFill>
+        <a:effectLst/>
       </p:bgPr>
     </p:bg>
     <p:spTree>
@@ -4810,6 +4549,13 @@
             <a:prstDash val="solid"/>
           </a:ln>
         </p:spPr>
+        <p:txBody>
+          <a:bodyPr/>
+          <a:lstStyle/>
+          <a:p>
+            <a:endParaRPr lang="en-US"/>
+          </a:p>
+        </p:txBody>
       </p:sp>
       <p:sp>
         <p:nvSpPr>
@@ -4832,11 +4578,11 @@
           <a:bodyPr wrap="square" lIns="0" tIns="0" rIns="0" bIns="0" rtlCol="0" anchor="ctr"/>
           <a:lstStyle/>
           <a:p>
-            <a:pPr indent="0" marL="0">
-              <a:buNone/>
-            </a:pPr>
-            <a:r>
-              <a:rPr lang="en-US" sz="1000" b="1" spc="200" kern="0" dirty="0">
+            <a:pPr marL="0" indent="0">
+              <a:buNone/>
+            </a:pPr>
+            <a:r>
+              <a:rPr lang="en-US" sz="1000" b="1" kern="0" spc="200" dirty="0">
                 <a:solidFill>
                   <a:srgbClr val="FFFFFF"/>
                 </a:solidFill>
@@ -4871,7 +4617,7 @@
           <a:bodyPr wrap="square" lIns="0" tIns="0" rIns="0" bIns="0" rtlCol="0" anchor="ctr"/>
           <a:lstStyle/>
           <a:p>
-            <a:pPr indent="0" marL="0">
+            <a:pPr marL="0" indent="0">
               <a:buNone/>
             </a:pPr>
             <a:r>
@@ -4910,7 +4656,7 @@
           <a:bodyPr wrap="square" lIns="0" tIns="0" rIns="0" bIns="0" rtlCol="0" anchor="ctr"/>
           <a:lstStyle/>
           <a:p>
-            <a:pPr indent="0" marL="0">
+            <a:pPr marL="0" indent="0">
               <a:buNone/>
             </a:pPr>
             <a:r>
@@ -4949,7 +4695,7 @@
           <a:bodyPr wrap="square" lIns="0" tIns="0" rIns="0" bIns="0" rtlCol="0" anchor="ctr"/>
           <a:lstStyle/>
           <a:p>
-            <a:pPr indent="0" marL="0">
+            <a:pPr marL="0" indent="0">
               <a:buNone/>
             </a:pPr>
             <a:r>
@@ -4983,6 +4729,7 @@
         <a:solidFill>
           <a:srgbClr val="FFFFFF"/>
         </a:solidFill>
+        <a:effectLst/>
       </p:bgPr>
     </p:bg>
     <p:spTree>
@@ -5020,7 +4767,7 @@
           <a:bodyPr wrap="square" lIns="0" tIns="0" rIns="0" bIns="0" rtlCol="0" anchor="ctr"/>
           <a:lstStyle/>
           <a:p>
-            <a:pPr indent="0" marL="0">
+            <a:pPr marL="0" indent="0">
               <a:buNone/>
             </a:pPr>
             <a:r>
@@ -5059,7 +4806,7 @@
           <a:bodyPr wrap="square" lIns="0" tIns="0" rIns="0" bIns="0" rtlCol="0" anchor="ctr"/>
           <a:lstStyle/>
           <a:p>
-            <a:pPr indent="0" marL="0">
+            <a:pPr marL="0" indent="0">
               <a:buNone/>
             </a:pPr>
             <a:r>
@@ -5098,7 +4845,7 @@
           <a:bodyPr wrap="square" lIns="0" tIns="0" rIns="0" bIns="0" rtlCol="0" anchor="ctr"/>
           <a:lstStyle/>
           <a:p>
-            <a:pPr indent="0" marL="0">
+            <a:pPr marL="0" indent="0">
               <a:buNone/>
             </a:pPr>
             <a:r>
@@ -5137,7 +4884,7 @@
           <a:bodyPr wrap="square" lIns="0" tIns="0" rIns="0" bIns="0" rtlCol="0" anchor="ctr"/>
           <a:lstStyle/>
           <a:p>
-            <a:pPr indent="0" marL="0">
+            <a:pPr marL="0" indent="0">
               <a:buNone/>
             </a:pPr>
             <a:r>
@@ -5252,7 +4999,7 @@
           <a:bodyPr wrap="square" lIns="0" tIns="0" rIns="0" bIns="0" rtlCol="0" anchor="ctr"/>
           <a:lstStyle/>
           <a:p>
-            <a:pPr indent="0" marL="0">
+            <a:pPr marL="0" indent="0">
               <a:buNone/>
             </a:pPr>
             <a:r>
@@ -5291,7 +5038,7 @@
           <a:bodyPr wrap="square" lIns="0" tIns="0" rIns="0" bIns="0" rtlCol="0" anchor="ctr"/>
           <a:lstStyle/>
           <a:p>
-            <a:pPr indent="0" marL="0">
+            <a:pPr marL="0" indent="0">
               <a:buNone/>
             </a:pPr>
             <a:r>
@@ -5330,7 +5077,7 @@
           <a:bodyPr wrap="square" lIns="0" tIns="0" rIns="0" bIns="0" rtlCol="0" anchor="ctr"/>
           <a:lstStyle/>
           <a:p>
-            <a:pPr indent="0" marL="0">
+            <a:pPr marL="0" indent="0">
               <a:buNone/>
             </a:pPr>
             <a:r>
@@ -5369,7 +5116,7 @@
           <a:bodyPr wrap="square" lIns="0" tIns="0" rIns="0" bIns="0" rtlCol="0" anchor="ctr"/>
           <a:lstStyle/>
           <a:p>
-            <a:pPr indent="0" marL="0">
+            <a:pPr marL="0" indent="0">
               <a:buNone/>
             </a:pPr>
             <a:r>
@@ -5408,7 +5155,7 @@
           <a:bodyPr wrap="square" lIns="0" tIns="0" rIns="0" bIns="0" rtlCol="0" anchor="ctr"/>
           <a:lstStyle/>
           <a:p>
-            <a:pPr algn="r" indent="0" marL="0">
+            <a:pPr marL="0" indent="0" algn="r">
               <a:buNone/>
             </a:pPr>
             <a:r>
@@ -5442,6 +5189,7 @@
         <a:solidFill>
           <a:srgbClr val="091A23"/>
         </a:solidFill>
+        <a:effectLst/>
       </p:bgPr>
     </p:bg>
     <p:spTree>
@@ -5479,7 +5227,7 @@
           <a:bodyPr wrap="square" lIns="0" tIns="0" rIns="0" bIns="0" rtlCol="0" anchor="ctr"/>
           <a:lstStyle/>
           <a:p>
-            <a:pPr indent="0" marL="0">
+            <a:pPr marL="0" indent="0">
               <a:buNone/>
             </a:pPr>
             <a:r>
@@ -5518,7 +5266,7 @@
           <a:bodyPr wrap="square" lIns="0" tIns="0" rIns="0" bIns="0" rtlCol="0" anchor="ctr"/>
           <a:lstStyle/>
           <a:p>
-            <a:pPr indent="0" marL="0">
+            <a:pPr marL="0" indent="0">
               <a:buNone/>
             </a:pPr>
             <a:r>
@@ -5560,6 +5308,13 @@
             <a:prstDash val="solid"/>
           </a:ln>
         </p:spPr>
+        <p:txBody>
+          <a:bodyPr/>
+          <a:lstStyle/>
+          <a:p>
+            <a:endParaRPr lang="en-US"/>
+          </a:p>
+        </p:txBody>
       </p:sp>
       <p:sp>
         <p:nvSpPr>
@@ -5585,6 +5340,13 @@
             <a:prstDash val="solid"/>
           </a:ln>
         </p:spPr>
+        <p:txBody>
+          <a:bodyPr/>
+          <a:lstStyle/>
+          <a:p>
+            <a:endParaRPr lang="en-US"/>
+          </a:p>
+        </p:txBody>
       </p:sp>
       <p:sp>
         <p:nvSpPr>
@@ -5607,11 +5369,11 @@
           <a:bodyPr wrap="square" lIns="0" tIns="0" rIns="0" bIns="0" rtlCol="0" anchor="ctr"/>
           <a:lstStyle/>
           <a:p>
-            <a:pPr indent="0" marL="0">
-              <a:buNone/>
-            </a:pPr>
-            <a:r>
-              <a:rPr lang="en-US" sz="900" b="1" spc="100" kern="0" dirty="0">
+            <a:pPr marL="0" indent="0">
+              <a:buNone/>
+            </a:pPr>
+            <a:r>
+              <a:rPr lang="en-US" sz="900" b="1" kern="0" spc="100" dirty="0">
                 <a:solidFill>
                   <a:srgbClr val="DCFF1E"/>
                 </a:solidFill>
@@ -5646,7 +5408,7 @@
           <a:bodyPr wrap="square" lIns="0" tIns="0" rIns="0" bIns="0" rtlCol="0" anchor="t"/>
           <a:lstStyle/>
           <a:p>
-            <a:pPr algn="l" indent="0" marL="0">
+            <a:pPr marL="0" indent="0" algn="l">
               <a:buNone/>
             </a:pPr>
             <a:r>
@@ -5688,6 +5450,13 @@
             <a:prstDash val="solid"/>
           </a:ln>
         </p:spPr>
+        <p:txBody>
+          <a:bodyPr/>
+          <a:lstStyle/>
+          <a:p>
+            <a:endParaRPr lang="en-US"/>
+          </a:p>
+        </p:txBody>
       </p:sp>
       <p:sp>
         <p:nvSpPr>
@@ -5713,6 +5482,13 @@
             <a:prstDash val="solid"/>
           </a:ln>
         </p:spPr>
+        <p:txBody>
+          <a:bodyPr/>
+          <a:lstStyle/>
+          <a:p>
+            <a:endParaRPr lang="en-US"/>
+          </a:p>
+        </p:txBody>
       </p:sp>
       <p:sp>
         <p:nvSpPr>
@@ -5735,11 +5511,11 @@
           <a:bodyPr wrap="square" lIns="0" tIns="0" rIns="0" bIns="0" rtlCol="0" anchor="ctr"/>
           <a:lstStyle/>
           <a:p>
-            <a:pPr indent="0" marL="0">
-              <a:buNone/>
-            </a:pPr>
-            <a:r>
-              <a:rPr lang="en-US" sz="900" b="1" spc="100" kern="0" dirty="0">
+            <a:pPr marL="0" indent="0">
+              <a:buNone/>
+            </a:pPr>
+            <a:r>
+              <a:rPr lang="en-US" sz="900" b="1" kern="0" spc="100" dirty="0">
                 <a:solidFill>
                   <a:srgbClr val="DCFF1E"/>
                 </a:solidFill>
@@ -5774,7 +5550,7 @@
           <a:bodyPr wrap="square" lIns="0" tIns="0" rIns="0" bIns="0" rtlCol="0" anchor="t"/>
           <a:lstStyle/>
           <a:p>
-            <a:pPr algn="l" indent="0" marL="0">
+            <a:pPr marL="0" indent="0" algn="l">
               <a:buNone/>
             </a:pPr>
             <a:r>
@@ -5816,6 +5592,13 @@
             <a:prstDash val="solid"/>
           </a:ln>
         </p:spPr>
+        <p:txBody>
+          <a:bodyPr/>
+          <a:lstStyle/>
+          <a:p>
+            <a:endParaRPr lang="en-US"/>
+          </a:p>
+        </p:txBody>
       </p:sp>
       <p:sp>
         <p:nvSpPr>
@@ -5841,6 +5624,13 @@
             <a:prstDash val="solid"/>
           </a:ln>
         </p:spPr>
+        <p:txBody>
+          <a:bodyPr/>
+          <a:lstStyle/>
+          <a:p>
+            <a:endParaRPr lang="en-US"/>
+          </a:p>
+        </p:txBody>
       </p:sp>
       <p:sp>
         <p:nvSpPr>
@@ -5863,11 +5653,11 @@
           <a:bodyPr wrap="square" lIns="0" tIns="0" rIns="0" bIns="0" rtlCol="0" anchor="ctr"/>
           <a:lstStyle/>
           <a:p>
-            <a:pPr indent="0" marL="0">
-              <a:buNone/>
-            </a:pPr>
-            <a:r>
-              <a:rPr lang="en-US" sz="900" b="1" spc="100" kern="0" dirty="0">
+            <a:pPr marL="0" indent="0">
+              <a:buNone/>
+            </a:pPr>
+            <a:r>
+              <a:rPr lang="en-US" sz="900" b="1" kern="0" spc="100" dirty="0">
                 <a:solidFill>
                   <a:srgbClr val="DCFF1E"/>
                 </a:solidFill>
@@ -5902,7 +5692,7 @@
           <a:bodyPr wrap="square" lIns="0" tIns="0" rIns="0" bIns="0" rtlCol="0" anchor="t"/>
           <a:lstStyle/>
           <a:p>
-            <a:pPr algn="l" indent="0" marL="0">
+            <a:pPr marL="0" indent="0" algn="l">
               <a:buNone/>
             </a:pPr>
             <a:r>
@@ -5941,7 +5731,7 @@
           <a:bodyPr wrap="square" lIns="0" tIns="0" rIns="0" bIns="0" rtlCol="0" anchor="ctr"/>
           <a:lstStyle/>
           <a:p>
-            <a:pPr indent="0" marL="0">
+            <a:pPr marL="0" indent="0">
               <a:buNone/>
             </a:pPr>
             <a:r>
@@ -5980,7 +5770,7 @@
           <a:bodyPr wrap="square" lIns="0" tIns="0" rIns="0" bIns="0" rtlCol="0" anchor="ctr"/>
           <a:lstStyle/>
           <a:p>
-            <a:pPr indent="0" marL="0">
+            <a:pPr marL="0" indent="0">
               <a:buNone/>
             </a:pPr>
             <a:r>
@@ -6019,7 +5809,7 @@
           <a:bodyPr wrap="square" lIns="0" tIns="0" rIns="0" bIns="0" rtlCol="0" anchor="ctr"/>
           <a:lstStyle/>
           <a:p>
-            <a:pPr algn="r" indent="0" marL="0">
+            <a:pPr marL="0" indent="0" algn="r">
               <a:buNone/>
             </a:pPr>
             <a:r>
@@ -6053,6 +5843,7 @@
         <a:solidFill>
           <a:srgbClr val="FFFFFF"/>
         </a:solidFill>
+        <a:effectLst/>
       </p:bgPr>
     </p:bg>
     <p:spTree>
@@ -6090,7 +5881,7 @@
           <a:bodyPr wrap="square" lIns="0" tIns="0" rIns="0" bIns="0" rtlCol="0" anchor="ctr"/>
           <a:lstStyle/>
           <a:p>
-            <a:pPr indent="0" marL="0">
+            <a:pPr marL="0" indent="0">
               <a:buNone/>
             </a:pPr>
             <a:r>
@@ -6129,7 +5920,7 @@
           <a:bodyPr wrap="square" lIns="0" tIns="0" rIns="0" bIns="0" rtlCol="0" anchor="ctr"/>
           <a:lstStyle/>
           <a:p>
-            <a:pPr indent="0" marL="0">
+            <a:pPr marL="0" indent="0">
               <a:buNone/>
             </a:pPr>
             <a:r>
@@ -6262,7 +6053,7 @@
           <a:bodyPr wrap="square" lIns="0" tIns="0" rIns="0" bIns="0" rtlCol="0" anchor="ctr"/>
           <a:lstStyle/>
           <a:p>
-            <a:pPr indent="0" marL="0">
+            <a:pPr marL="0" indent="0">
               <a:buNone/>
             </a:pPr>
             <a:r>
@@ -6301,7 +6092,7 @@
           <a:bodyPr wrap="square" lIns="0" tIns="0" rIns="0" bIns="0" rtlCol="0" anchor="ctr"/>
           <a:lstStyle/>
           <a:p>
-            <a:pPr indent="0" marL="0">
+            <a:pPr marL="0" indent="0">
               <a:buNone/>
             </a:pPr>
             <a:r>
@@ -6340,7 +6131,7 @@
           <a:bodyPr wrap="square" lIns="0" tIns="0" rIns="0" bIns="0" rtlCol="0" anchor="ctr"/>
           <a:lstStyle/>
           <a:p>
-            <a:pPr algn="r" indent="0" marL="0">
+            <a:pPr marL="0" indent="0" algn="r">
               <a:buNone/>
             </a:pPr>
             <a:r>
@@ -6374,6 +6165,7 @@
         <a:solidFill>
           <a:srgbClr val="FFFFFF"/>
         </a:solidFill>
+        <a:effectLst/>
       </p:bgPr>
     </p:bg>
     <p:spTree>
@@ -6411,7 +6203,7 @@
           <a:bodyPr wrap="square" lIns="0" tIns="0" rIns="0" bIns="0" rtlCol="0" anchor="ctr"/>
           <a:lstStyle/>
           <a:p>
-            <a:pPr indent="0" marL="0">
+            <a:pPr marL="0" indent="0">
               <a:buNone/>
             </a:pPr>
             <a:r>
@@ -6450,7 +6242,7 @@
           <a:bodyPr wrap="square" lIns="0" tIns="0" rIns="0" bIns="0" rtlCol="0" anchor="ctr"/>
           <a:lstStyle/>
           <a:p>
-            <a:pPr indent="0" marL="0">
+            <a:pPr marL="0" indent="0">
               <a:buNone/>
             </a:pPr>
             <a:r>
@@ -6489,7 +6281,7 @@
           <a:bodyPr wrap="square" lIns="0" tIns="0" rIns="0" bIns="0" rtlCol="0" anchor="ctr"/>
           <a:lstStyle/>
           <a:p>
-            <a:pPr indent="0" marL="0">
+            <a:pPr marL="0" indent="0">
               <a:buNone/>
             </a:pPr>
             <a:r>
@@ -6528,7 +6320,7 @@
           <a:bodyPr wrap="square" lIns="0" tIns="0" rIns="0" bIns="0" rtlCol="0" anchor="ctr"/>
           <a:lstStyle/>
           <a:p>
-            <a:pPr indent="0" marL="0">
+            <a:pPr marL="0" indent="0">
               <a:buNone/>
             </a:pPr>
             <a:r>
@@ -6643,7 +6435,7 @@
           <a:bodyPr wrap="square" lIns="0" tIns="0" rIns="0" bIns="0" rtlCol="0" anchor="ctr"/>
           <a:lstStyle/>
           <a:p>
-            <a:pPr indent="0" marL="0">
+            <a:pPr marL="0" indent="0">
               <a:buNone/>
             </a:pPr>
             <a:r>
@@ -6682,7 +6474,7 @@
           <a:bodyPr wrap="square" lIns="0" tIns="0" rIns="0" bIns="0" rtlCol="0" anchor="ctr"/>
           <a:lstStyle/>
           <a:p>
-            <a:pPr indent="0" marL="0">
+            <a:pPr marL="0" indent="0">
               <a:buNone/>
             </a:pPr>
             <a:r>
@@ -6721,7 +6513,7 @@
           <a:bodyPr wrap="square" lIns="0" tIns="0" rIns="0" bIns="0" rtlCol="0" anchor="ctr"/>
           <a:lstStyle/>
           <a:p>
-            <a:pPr indent="0" marL="0">
+            <a:pPr marL="0" indent="0">
               <a:buNone/>
             </a:pPr>
             <a:r>
@@ -6760,7 +6552,7 @@
           <a:bodyPr wrap="square" lIns="0" tIns="0" rIns="0" bIns="0" rtlCol="0" anchor="ctr"/>
           <a:lstStyle/>
           <a:p>
-            <a:pPr indent="0" marL="0">
+            <a:pPr marL="0" indent="0">
               <a:buNone/>
             </a:pPr>
             <a:r>
@@ -6799,7 +6591,7 @@
           <a:bodyPr wrap="square" lIns="0" tIns="0" rIns="0" bIns="0" rtlCol="0" anchor="ctr"/>
           <a:lstStyle/>
           <a:p>
-            <a:pPr algn="r" indent="0" marL="0">
+            <a:pPr marL="0" indent="0" algn="r">
               <a:buNone/>
             </a:pPr>
             <a:r>
@@ -6833,6 +6625,7 @@
         <a:solidFill>
           <a:srgbClr val="091A23"/>
         </a:solidFill>
+        <a:effectLst/>
       </p:bgPr>
     </p:bg>
     <p:spTree>
@@ -6870,7 +6663,7 @@
           <a:bodyPr wrap="square" lIns="0" tIns="0" rIns="0" bIns="0" rtlCol="0" anchor="ctr"/>
           <a:lstStyle/>
           <a:p>
-            <a:pPr indent="0" marL="0">
+            <a:pPr marL="0" indent="0">
               <a:buNone/>
             </a:pPr>
             <a:r>
@@ -6909,7 +6702,7 @@
           <a:bodyPr wrap="square" lIns="0" tIns="0" rIns="0" bIns="0" rtlCol="0" anchor="ctr"/>
           <a:lstStyle/>
           <a:p>
-            <a:pPr indent="0" marL="0">
+            <a:pPr marL="0" indent="0">
               <a:buNone/>
             </a:pPr>
             <a:r>
@@ -6951,6 +6744,13 @@
             <a:prstDash val="solid"/>
           </a:ln>
         </p:spPr>
+        <p:txBody>
+          <a:bodyPr/>
+          <a:lstStyle/>
+          <a:p>
+            <a:endParaRPr lang="en-US"/>
+          </a:p>
+        </p:txBody>
       </p:sp>
       <p:sp>
         <p:nvSpPr>
@@ -6976,6 +6776,13 @@
             <a:prstDash val="solid"/>
           </a:ln>
         </p:spPr>
+        <p:txBody>
+          <a:bodyPr/>
+          <a:lstStyle/>
+          <a:p>
+            <a:endParaRPr lang="en-US"/>
+          </a:p>
+        </p:txBody>
       </p:sp>
       <p:sp>
         <p:nvSpPr>
@@ -6998,11 +6805,11 @@
           <a:bodyPr wrap="square" lIns="0" tIns="0" rIns="0" bIns="0" rtlCol="0" anchor="ctr"/>
           <a:lstStyle/>
           <a:p>
-            <a:pPr indent="0" marL="0">
-              <a:buNone/>
-            </a:pPr>
-            <a:r>
-              <a:rPr lang="en-US" sz="900" b="1" spc="100" kern="0" dirty="0">
+            <a:pPr marL="0" indent="0">
+              <a:buNone/>
+            </a:pPr>
+            <a:r>
+              <a:rPr lang="en-US" sz="900" b="1" kern="0" spc="100" dirty="0">
                 <a:solidFill>
                   <a:srgbClr val="DCFF1E"/>
                 </a:solidFill>
@@ -7037,7 +6844,7 @@
           <a:bodyPr wrap="square" lIns="0" tIns="0" rIns="0" bIns="0" rtlCol="0" anchor="t"/>
           <a:lstStyle/>
           <a:p>
-            <a:pPr algn="l" indent="0" marL="0">
+            <a:pPr marL="0" indent="0" algn="l">
               <a:buNone/>
             </a:pPr>
             <a:r>
@@ -7079,6 +6886,13 @@
             <a:prstDash val="solid"/>
           </a:ln>
         </p:spPr>
+        <p:txBody>
+          <a:bodyPr/>
+          <a:lstStyle/>
+          <a:p>
+            <a:endParaRPr lang="en-US"/>
+          </a:p>
+        </p:txBody>
       </p:sp>
       <p:sp>
         <p:nvSpPr>
@@ -7104,6 +6918,13 @@
             <a:prstDash val="solid"/>
           </a:ln>
         </p:spPr>
+        <p:txBody>
+          <a:bodyPr/>
+          <a:lstStyle/>
+          <a:p>
+            <a:endParaRPr lang="en-US"/>
+          </a:p>
+        </p:txBody>
       </p:sp>
       <p:sp>
         <p:nvSpPr>
@@ -7126,11 +6947,11 @@
           <a:bodyPr wrap="square" lIns="0" tIns="0" rIns="0" bIns="0" rtlCol="0" anchor="ctr"/>
           <a:lstStyle/>
           <a:p>
-            <a:pPr indent="0" marL="0">
-              <a:buNone/>
-            </a:pPr>
-            <a:r>
-              <a:rPr lang="en-US" sz="900" b="1" spc="100" kern="0" dirty="0">
+            <a:pPr marL="0" indent="0">
+              <a:buNone/>
+            </a:pPr>
+            <a:r>
+              <a:rPr lang="en-US" sz="900" b="1" kern="0" spc="100" dirty="0">
                 <a:solidFill>
                   <a:srgbClr val="DCFF1E"/>
                 </a:solidFill>
@@ -7165,7 +6986,7 @@
           <a:bodyPr wrap="square" lIns="0" tIns="0" rIns="0" bIns="0" rtlCol="0" anchor="t"/>
           <a:lstStyle/>
           <a:p>
-            <a:pPr algn="l" indent="0" marL="0">
+            <a:pPr marL="0" indent="0" algn="l">
               <a:buNone/>
             </a:pPr>
             <a:r>
@@ -7207,6 +7028,13 @@
             <a:prstDash val="solid"/>
           </a:ln>
         </p:spPr>
+        <p:txBody>
+          <a:bodyPr/>
+          <a:lstStyle/>
+          <a:p>
+            <a:endParaRPr lang="en-US"/>
+          </a:p>
+        </p:txBody>
       </p:sp>
       <p:sp>
         <p:nvSpPr>
@@ -7232,6 +7060,13 @@
             <a:prstDash val="solid"/>
           </a:ln>
         </p:spPr>
+        <p:txBody>
+          <a:bodyPr/>
+          <a:lstStyle/>
+          <a:p>
+            <a:endParaRPr lang="en-US"/>
+          </a:p>
+        </p:txBody>
       </p:sp>
       <p:sp>
         <p:nvSpPr>
@@ -7254,11 +7089,11 @@
           <a:bodyPr wrap="square" lIns="0" tIns="0" rIns="0" bIns="0" rtlCol="0" anchor="ctr"/>
           <a:lstStyle/>
           <a:p>
-            <a:pPr indent="0" marL="0">
-              <a:buNone/>
-            </a:pPr>
-            <a:r>
-              <a:rPr lang="en-US" sz="900" b="1" spc="100" kern="0" dirty="0">
+            <a:pPr marL="0" indent="0">
+              <a:buNone/>
+            </a:pPr>
+            <a:r>
+              <a:rPr lang="en-US" sz="900" b="1" kern="0" spc="100" dirty="0">
                 <a:solidFill>
                   <a:srgbClr val="DCFF1E"/>
                 </a:solidFill>
@@ -7293,7 +7128,7 @@
           <a:bodyPr wrap="square" lIns="0" tIns="0" rIns="0" bIns="0" rtlCol="0" anchor="t"/>
           <a:lstStyle/>
           <a:p>
-            <a:pPr algn="l" indent="0" marL="0">
+            <a:pPr marL="0" indent="0" algn="l">
               <a:buNone/>
             </a:pPr>
             <a:r>
@@ -7332,7 +7167,7 @@
           <a:bodyPr wrap="square" lIns="0" tIns="0" rIns="0" bIns="0" rtlCol="0" anchor="ctr"/>
           <a:lstStyle/>
           <a:p>
-            <a:pPr indent="0" marL="0">
+            <a:pPr marL="0" indent="0">
               <a:buNone/>
             </a:pPr>
             <a:r>
@@ -7371,7 +7206,7 @@
           <a:bodyPr wrap="square" lIns="0" tIns="0" rIns="0" bIns="0" rtlCol="0" anchor="ctr"/>
           <a:lstStyle/>
           <a:p>
-            <a:pPr indent="0" marL="0">
+            <a:pPr marL="0" indent="0">
               <a:buNone/>
             </a:pPr>
             <a:r>
@@ -7410,7 +7245,7 @@
           <a:bodyPr wrap="square" lIns="0" tIns="0" rIns="0" bIns="0" rtlCol="0" anchor="ctr"/>
           <a:lstStyle/>
           <a:p>
-            <a:pPr algn="r" indent="0" marL="0">
+            <a:pPr marL="0" indent="0" algn="r">
               <a:buNone/>
             </a:pPr>
             <a:r>
@@ -7444,6 +7279,7 @@
         <a:solidFill>
           <a:srgbClr val="FFFFFF"/>
         </a:solidFill>
+        <a:effectLst/>
       </p:bgPr>
     </p:bg>
     <p:spTree>
@@ -7481,7 +7317,7 @@
           <a:bodyPr wrap="square" lIns="0" tIns="0" rIns="0" bIns="0" rtlCol="0" anchor="ctr"/>
           <a:lstStyle/>
           <a:p>
-            <a:pPr indent="0" marL="0">
+            <a:pPr marL="0" indent="0">
               <a:buNone/>
             </a:pPr>
             <a:r>
@@ -7520,7 +7356,7 @@
           <a:bodyPr wrap="square" lIns="0" tIns="0" rIns="0" bIns="0" rtlCol="0" anchor="ctr"/>
           <a:lstStyle/>
           <a:p>
-            <a:pPr indent="0" marL="0">
+            <a:pPr marL="0" indent="0">
               <a:buNone/>
             </a:pPr>
             <a:r>
@@ -7562,6 +7398,13 @@
             <a:prstDash val="solid"/>
           </a:ln>
         </p:spPr>
+        <p:txBody>
+          <a:bodyPr/>
+          <a:lstStyle/>
+          <a:p>
+            <a:endParaRPr lang="en-US"/>
+          </a:p>
+        </p:txBody>
       </p:sp>
       <p:sp>
         <p:nvSpPr>
@@ -7584,7 +7427,7 @@
           <a:bodyPr wrap="square" lIns="0" tIns="0" rIns="0" bIns="0" rtlCol="0" anchor="ctr"/>
           <a:lstStyle/>
           <a:p>
-            <a:pPr indent="0" marL="0">
+            <a:pPr marL="0" indent="0">
               <a:buNone/>
             </a:pPr>
             <a:r>
@@ -7623,7 +7466,7 @@
           <a:bodyPr wrap="square" lIns="0" tIns="0" rIns="0" bIns="0" rtlCol="0" anchor="ctr"/>
           <a:lstStyle/>
           <a:p>
-            <a:pPr indent="0" marL="0">
+            <a:pPr marL="0" indent="0">
               <a:buNone/>
             </a:pPr>
             <a:r>
@@ -7665,6 +7508,13 @@
             <a:prstDash val="solid"/>
           </a:ln>
         </p:spPr>
+        <p:txBody>
+          <a:bodyPr/>
+          <a:lstStyle/>
+          <a:p>
+            <a:endParaRPr lang="en-US"/>
+          </a:p>
+        </p:txBody>
       </p:sp>
       <p:sp>
         <p:nvSpPr>
@@ -7687,7 +7537,7 @@
           <a:bodyPr wrap="square" lIns="0" tIns="0" rIns="0" bIns="0" rtlCol="0" anchor="ctr"/>
           <a:lstStyle/>
           <a:p>
-            <a:pPr indent="0" marL="0">
+            <a:pPr marL="0" indent="0">
               <a:buNone/>
             </a:pPr>
             <a:r>
@@ -7726,7 +7576,7 @@
           <a:bodyPr wrap="square" lIns="0" tIns="0" rIns="0" bIns="0" rtlCol="0" anchor="ctr"/>
           <a:lstStyle/>
           <a:p>
-            <a:pPr indent="0" marL="0">
+            <a:pPr marL="0" indent="0">
               <a:buNone/>
             </a:pPr>
             <a:r>
@@ -7768,6 +7618,13 @@
             <a:prstDash val="solid"/>
           </a:ln>
         </p:spPr>
+        <p:txBody>
+          <a:bodyPr/>
+          <a:lstStyle/>
+          <a:p>
+            <a:endParaRPr lang="en-US"/>
+          </a:p>
+        </p:txBody>
       </p:sp>
       <p:sp>
         <p:nvSpPr>
@@ -7790,7 +7647,7 @@
           <a:bodyPr wrap="square" lIns="0" tIns="0" rIns="0" bIns="0" rtlCol="0" anchor="ctr"/>
           <a:lstStyle/>
           <a:p>
-            <a:pPr indent="0" marL="0">
+            <a:pPr marL="0" indent="0">
               <a:buNone/>
             </a:pPr>
             <a:r>
@@ -7829,7 +7686,7 @@
           <a:bodyPr wrap="square" lIns="0" tIns="0" rIns="0" bIns="0" rtlCol="0" anchor="ctr"/>
           <a:lstStyle/>
           <a:p>
-            <a:pPr indent="0" marL="0">
+            <a:pPr marL="0" indent="0">
               <a:buNone/>
             </a:pPr>
             <a:r>
@@ -7846,7 +7703,7 @@
             <a:endParaRPr lang="en-US" sz="850" dirty="0"/>
           </a:p>
           <a:p>
-            <a:pPr indent="0" marL="0">
+            <a:pPr marL="0" indent="0">
               <a:buNone/>
             </a:pPr>
             <a:r>
@@ -7888,6 +7745,13 @@
             <a:prstDash val="solid"/>
           </a:ln>
         </p:spPr>
+        <p:txBody>
+          <a:bodyPr/>
+          <a:lstStyle/>
+          <a:p>
+            <a:endParaRPr lang="en-US"/>
+          </a:p>
+        </p:txBody>
       </p:sp>
       <p:sp>
         <p:nvSpPr>
@@ -7910,7 +7774,7 @@
           <a:bodyPr wrap="square" lIns="0" tIns="0" rIns="0" bIns="0" rtlCol="0" anchor="ctr"/>
           <a:lstStyle/>
           <a:p>
-            <a:pPr indent="0" marL="0">
+            <a:pPr marL="0" indent="0">
               <a:buNone/>
             </a:pPr>
             <a:r>
@@ -7949,7 +7813,7 @@
           <a:bodyPr wrap="square" lIns="0" tIns="0" rIns="0" bIns="0" rtlCol="0" anchor="ctr"/>
           <a:lstStyle/>
           <a:p>
-            <a:pPr indent="0" marL="0">
+            <a:pPr marL="0" indent="0">
               <a:buNone/>
             </a:pPr>
             <a:r>
@@ -7966,7 +7830,7 @@
             <a:endParaRPr lang="en-US" sz="850" dirty="0"/>
           </a:p>
           <a:p>
-            <a:pPr indent="0" marL="0">
+            <a:pPr marL="0" indent="0">
               <a:buNone/>
             </a:pPr>
             <a:r>
@@ -8008,6 +7872,13 @@
             <a:prstDash val="solid"/>
           </a:ln>
         </p:spPr>
+        <p:txBody>
+          <a:bodyPr/>
+          <a:lstStyle/>
+          <a:p>
+            <a:endParaRPr lang="en-US"/>
+          </a:p>
+        </p:txBody>
       </p:sp>
       <p:sp>
         <p:nvSpPr>
@@ -8030,7 +7901,7 @@
           <a:bodyPr wrap="square" lIns="0" tIns="0" rIns="0" bIns="0" rtlCol="0" anchor="ctr"/>
           <a:lstStyle/>
           <a:p>
-            <a:pPr indent="0" marL="0">
+            <a:pPr marL="0" indent="0">
               <a:buNone/>
             </a:pPr>
             <a:r>
@@ -8069,7 +7940,7 @@
           <a:bodyPr wrap="square" lIns="0" tIns="0" rIns="0" bIns="0" rtlCol="0" anchor="ctr"/>
           <a:lstStyle/>
           <a:p>
-            <a:pPr indent="0" marL="0">
+            <a:pPr marL="0" indent="0">
               <a:buNone/>
             </a:pPr>
             <a:r>
@@ -8086,7 +7957,7 @@
             <a:endParaRPr lang="en-US" sz="850" dirty="0"/>
           </a:p>
           <a:p>
-            <a:pPr indent="0" marL="0">
+            <a:pPr marL="0" indent="0">
               <a:buNone/>
             </a:pPr>
             <a:r>
@@ -8127,6 +7998,13 @@
             <a:tailEnd type="arrow"/>
           </a:ln>
         </p:spPr>
+        <p:txBody>
+          <a:bodyPr/>
+          <a:lstStyle/>
+          <a:p>
+            <a:endParaRPr lang="en-US"/>
+          </a:p>
+        </p:txBody>
       </p:sp>
       <p:sp>
         <p:nvSpPr>
@@ -8151,6 +8029,13 @@
             <a:tailEnd type="arrow"/>
           </a:ln>
         </p:spPr>
+        <p:txBody>
+          <a:bodyPr/>
+          <a:lstStyle/>
+          <a:p>
+            <a:endParaRPr lang="en-US"/>
+          </a:p>
+        </p:txBody>
       </p:sp>
       <p:sp>
         <p:nvSpPr>
@@ -8175,6 +8060,13 @@
             <a:tailEnd type="arrow"/>
           </a:ln>
         </p:spPr>
+        <p:txBody>
+          <a:bodyPr/>
+          <a:lstStyle/>
+          <a:p>
+            <a:endParaRPr lang="en-US"/>
+          </a:p>
+        </p:txBody>
       </p:sp>
       <p:sp>
         <p:nvSpPr>
@@ -8199,6 +8091,13 @@
             <a:tailEnd type="arrow"/>
           </a:ln>
         </p:spPr>
+        <p:txBody>
+          <a:bodyPr/>
+          <a:lstStyle/>
+          <a:p>
+            <a:endParaRPr lang="en-US"/>
+          </a:p>
+        </p:txBody>
       </p:sp>
       <p:sp>
         <p:nvSpPr>
@@ -8223,6 +8122,13 @@
             <a:tailEnd type="arrow"/>
           </a:ln>
         </p:spPr>
+        <p:txBody>
+          <a:bodyPr/>
+          <a:lstStyle/>
+          <a:p>
+            <a:endParaRPr lang="en-US"/>
+          </a:p>
+        </p:txBody>
       </p:sp>
       <p:sp>
         <p:nvSpPr>
@@ -8247,6 +8153,13 @@
             <a:tailEnd type="arrow"/>
           </a:ln>
         </p:spPr>
+        <p:txBody>
+          <a:bodyPr/>
+          <a:lstStyle/>
+          <a:p>
+            <a:endParaRPr lang="en-US"/>
+          </a:p>
+        </p:txBody>
       </p:sp>
       <p:sp>
         <p:nvSpPr>
@@ -8269,7 +8182,7 @@
           <a:bodyPr wrap="square" lIns="0" tIns="0" rIns="0" bIns="0" rtlCol="0" anchor="ctr"/>
           <a:lstStyle/>
           <a:p>
-            <a:pPr indent="0" marL="0">
+            <a:pPr marL="0" indent="0">
               <a:buNone/>
             </a:pPr>
             <a:r>
@@ -8286,7 +8199,7 @@
             <a:endParaRPr lang="en-US" sz="1000" dirty="0"/>
           </a:p>
           <a:p>
-            <a:pPr indent="0" marL="0">
+            <a:pPr marL="0" indent="0">
               <a:buNone/>
             </a:pPr>
             <a:r>
@@ -8325,7 +8238,7 @@
           <a:bodyPr wrap="square" lIns="0" tIns="0" rIns="0" bIns="0" rtlCol="0" anchor="ctr"/>
           <a:lstStyle/>
           <a:p>
-            <a:pPr indent="0" marL="0">
+            <a:pPr marL="0" indent="0">
               <a:buNone/>
             </a:pPr>
             <a:r>
@@ -8364,7 +8277,7 @@
           <a:bodyPr wrap="square" lIns="0" tIns="0" rIns="0" bIns="0" rtlCol="0" anchor="ctr"/>
           <a:lstStyle/>
           <a:p>
-            <a:pPr indent="0" marL="0">
+            <a:pPr marL="0" indent="0">
               <a:buNone/>
             </a:pPr>
             <a:r>
@@ -8403,7 +8316,7 @@
           <a:bodyPr wrap="square" lIns="0" tIns="0" rIns="0" bIns="0" rtlCol="0" anchor="ctr"/>
           <a:lstStyle/>
           <a:p>
-            <a:pPr algn="r" indent="0" marL="0">
+            <a:pPr marL="0" indent="0" algn="r">
               <a:buNone/>
             </a:pPr>
             <a:r>
@@ -8437,6 +8350,7 @@
         <a:solidFill>
           <a:srgbClr val="FFFFFF"/>
         </a:solidFill>
+        <a:effectLst/>
       </p:bgPr>
     </p:bg>
     <p:spTree>
@@ -8474,7 +8388,7 @@
           <a:bodyPr wrap="square" lIns="0" tIns="0" rIns="0" bIns="0" rtlCol="0" anchor="ctr"/>
           <a:lstStyle/>
           <a:p>
-            <a:pPr indent="0" marL="0">
+            <a:pPr marL="0" indent="0">
               <a:buNone/>
             </a:pPr>
             <a:r>
@@ -8513,7 +8427,7 @@
           <a:bodyPr wrap="square" lIns="0" tIns="0" rIns="0" bIns="0" rtlCol="0" anchor="ctr"/>
           <a:lstStyle/>
           <a:p>
-            <a:pPr indent="0" marL="0">
+            <a:pPr marL="0" indent="0">
               <a:buNone/>
             </a:pPr>
             <a:r>
@@ -8547,16 +8461,34 @@
         </p:nvGraphicFramePr>
         <p:xfrm>
           <a:off x="384048" y="1078992"/>
-          <a:ext cx="8412480" cy="914400"/>
+          <a:ext cx="8412480" cy="1965960"/>
         </p:xfrm>
         <a:graphic>
           <a:graphicData uri="http://schemas.openxmlformats.org/drawingml/2006/table">
             <a:tbl>
               <a:tblPr/>
               <a:tblGrid>
-                <a:gridCol w="1737360"/>
-                <a:gridCol w="4846320"/>
-                <a:gridCol w="1828800"/>
+                <a:gridCol w="1737360">
+                  <a:extLst>
+                    <a:ext uri="{9D8B030D-6E8A-4147-A177-3AD203B41FA5}">
+                      <a16:colId xmlns:a16="http://schemas.microsoft.com/office/drawing/2014/main" val="20000"/>
+                    </a:ext>
+                  </a:extLst>
+                </a:gridCol>
+                <a:gridCol w="4846320">
+                  <a:extLst>
+                    <a:ext uri="{9D8B030D-6E8A-4147-A177-3AD203B41FA5}">
+                      <a16:colId xmlns:a16="http://schemas.microsoft.com/office/drawing/2014/main" val="20001"/>
+                    </a:ext>
+                  </a:extLst>
+                </a:gridCol>
+                <a:gridCol w="1828800">
+                  <a:extLst>
+                    <a:ext uri="{9D8B030D-6E8A-4147-A177-3AD203B41FA5}">
+                      <a16:colId xmlns:a16="http://schemas.microsoft.com/office/drawing/2014/main" val="20002"/>
+                    </a:ext>
+                  </a:extLst>
+                </a:gridCol>
               </a:tblGrid>
               <a:tr h="274320">
                 <a:tc>
@@ -8564,7 +8496,7 @@
                     <a:bodyPr/>
                     <a:lstStyle/>
                     <a:p>
-                      <a:pPr indent="0" marL="0">
+                      <a:pPr marL="0" indent="0">
                         <a:buNone/>
                       </a:pPr>
                       <a:r>
@@ -8585,7 +8517,7 @@
                       </a:endParaRPr>
                     </a:p>
                   </a:txBody>
-                  <a:tcPr marL="91440" marR="91440" marT="45720" marB="45720" anchor="ctr">
+                  <a:tcPr anchor="ctr">
                     <a:lnL w="6350" cap="flat" cmpd="sng" algn="ctr">
                       <a:solidFill>
                         <a:srgbClr val="B9C2C6"/>
@@ -8632,7 +8564,7 @@
                     <a:bodyPr/>
                     <a:lstStyle/>
                     <a:p>
-                      <a:pPr indent="0" marL="0">
+                      <a:pPr marL="0" indent="0">
                         <a:buNone/>
                       </a:pPr>
                       <a:r>
@@ -8653,7 +8585,7 @@
                       </a:endParaRPr>
                     </a:p>
                   </a:txBody>
-                  <a:tcPr marL="91440" marR="91440" marT="45720" marB="45720" anchor="ctr">
+                  <a:tcPr anchor="ctr">
                     <a:lnL w="6350" cap="flat" cmpd="sng" algn="ctr">
                       <a:solidFill>
                         <a:srgbClr val="B9C2C6"/>
@@ -8700,7 +8632,7 @@
                     <a:bodyPr/>
                     <a:lstStyle/>
                     <a:p>
-                      <a:pPr indent="0" marL="0">
+                      <a:pPr marL="0" indent="0">
                         <a:buNone/>
                       </a:pPr>
                       <a:r>
@@ -8721,7 +8653,7 @@
                       </a:endParaRPr>
                     </a:p>
                   </a:txBody>
-                  <a:tcPr marL="91440" marR="91440" marT="45720" marB="45720" anchor="ctr">
+                  <a:tcPr anchor="ctr">
                     <a:lnL w="6350" cap="flat" cmpd="sng" algn="ctr">
                       <a:solidFill>
                         <a:srgbClr val="B9C2C6"/>
@@ -8763,6 +8695,11 @@
                     </a:solidFill>
                   </a:tcPr>
                 </a:tc>
+                <a:extLst>
+                  <a:ext uri="{0D108BD9-81ED-4DB2-BD59-A6C34878D82A}">
+                    <a16:rowId xmlns:a16="http://schemas.microsoft.com/office/drawing/2014/main" val="10000"/>
+                  </a:ext>
+                </a:extLst>
               </a:tr>
               <a:tr h="274320">
                 <a:tc>
@@ -8770,7 +8707,7 @@
                     <a:bodyPr/>
                     <a:lstStyle/>
                     <a:p>
-                      <a:pPr indent="0" marL="0">
+                      <a:pPr marL="0" indent="0">
                         <a:buNone/>
                       </a:pPr>
                       <a:r>
@@ -8791,7 +8728,7 @@
                       </a:endParaRPr>
                     </a:p>
                   </a:txBody>
-                  <a:tcPr marL="91440" marR="91440" marT="45720" marB="45720" anchor="ctr">
+                  <a:tcPr anchor="ctr">
                     <a:lnL w="6350" cap="flat" cmpd="sng" algn="ctr">
                       <a:solidFill>
                         <a:srgbClr val="B9C2C6"/>
@@ -8838,7 +8775,7 @@
                     <a:bodyPr/>
                     <a:lstStyle/>
                     <a:p>
-                      <a:pPr indent="0" marL="0">
+                      <a:pPr marL="0" indent="0">
                         <a:buNone/>
                       </a:pPr>
                       <a:r>
@@ -8859,7 +8796,7 @@
                       </a:endParaRPr>
                     </a:p>
                   </a:txBody>
-                  <a:tcPr marL="91440" marR="91440" marT="45720" marB="45720" anchor="ctr">
+                  <a:tcPr anchor="ctr">
                     <a:lnL w="6350" cap="flat" cmpd="sng" algn="ctr">
                       <a:solidFill>
                         <a:srgbClr val="B9C2C6"/>
@@ -8906,7 +8843,7 @@
                     <a:bodyPr/>
                     <a:lstStyle/>
                     <a:p>
-                      <a:pPr indent="0" marL="0">
+                      <a:pPr marL="0" indent="0">
                         <a:buNone/>
                       </a:pPr>
                       <a:r>
@@ -8927,7 +8864,7 @@
                       </a:endParaRPr>
                     </a:p>
                   </a:txBody>
-                  <a:tcPr marL="91440" marR="91440" marT="45720" marB="45720" anchor="ctr">
+                  <a:tcPr anchor="ctr">
                     <a:lnL w="6350" cap="flat" cmpd="sng" algn="ctr">
                       <a:solidFill>
                         <a:srgbClr val="B9C2C6"/>
@@ -8969,6 +8906,11 @@
                     </a:solidFill>
                   </a:tcPr>
                 </a:tc>
+                <a:extLst>
+                  <a:ext uri="{0D108BD9-81ED-4DB2-BD59-A6C34878D82A}">
+                    <a16:rowId xmlns:a16="http://schemas.microsoft.com/office/drawing/2014/main" val="10001"/>
+                  </a:ext>
+                </a:extLst>
               </a:tr>
               <a:tr h="274320">
                 <a:tc>
@@ -8976,7 +8918,7 @@
                     <a:bodyPr/>
                     <a:lstStyle/>
                     <a:p>
-                      <a:pPr indent="0" marL="0">
+                      <a:pPr marL="0" indent="0">
                         <a:buNone/>
                       </a:pPr>
                       <a:r>
@@ -8997,7 +8939,7 @@
                       </a:endParaRPr>
                     </a:p>
                   </a:txBody>
-                  <a:tcPr marL="91440" marR="91440" marT="45720" marB="45720" anchor="ctr">
+                  <a:tcPr anchor="ctr">
                     <a:lnL w="6350" cap="flat" cmpd="sng" algn="ctr">
                       <a:solidFill>
                         <a:srgbClr val="B9C2C6"/>
@@ -9044,7 +8986,7 @@
                     <a:bodyPr/>
                     <a:lstStyle/>
                     <a:p>
-                      <a:pPr indent="0" marL="0">
+                      <a:pPr marL="0" indent="0">
                         <a:buNone/>
                       </a:pPr>
                       <a:r>
@@ -9065,7 +9007,7 @@
                       </a:endParaRPr>
                     </a:p>
                   </a:txBody>
-                  <a:tcPr marL="91440" marR="91440" marT="45720" marB="45720" anchor="ctr">
+                  <a:tcPr anchor="ctr">
                     <a:lnL w="6350" cap="flat" cmpd="sng" algn="ctr">
                       <a:solidFill>
                         <a:srgbClr val="B9C2C6"/>
@@ -9112,7 +9054,7 @@
                     <a:bodyPr/>
                     <a:lstStyle/>
                     <a:p>
-                      <a:pPr indent="0" marL="0">
+                      <a:pPr marL="0" indent="0">
                         <a:buNone/>
                       </a:pPr>
                       <a:r>
@@ -9133,7 +9075,7 @@
                       </a:endParaRPr>
                     </a:p>
                   </a:txBody>
-                  <a:tcPr marL="91440" marR="91440" marT="45720" marB="45720" anchor="ctr">
+                  <a:tcPr anchor="ctr">
                     <a:lnL w="6350" cap="flat" cmpd="sng" algn="ctr">
                       <a:solidFill>
                         <a:srgbClr val="B9C2C6"/>
@@ -9175,6 +9117,11 @@
                     </a:solidFill>
                   </a:tcPr>
                 </a:tc>
+                <a:extLst>
+                  <a:ext uri="{0D108BD9-81ED-4DB2-BD59-A6C34878D82A}">
+                    <a16:rowId xmlns:a16="http://schemas.microsoft.com/office/drawing/2014/main" val="10002"/>
+                  </a:ext>
+                </a:extLst>
               </a:tr>
               <a:tr h="274320">
                 <a:tc>
@@ -9182,7 +9129,7 @@
                     <a:bodyPr/>
                     <a:lstStyle/>
                     <a:p>
-                      <a:pPr indent="0" marL="0">
+                      <a:pPr marL="0" indent="0">
                         <a:buNone/>
                       </a:pPr>
                       <a:r>
@@ -9203,7 +9150,7 @@
                       </a:endParaRPr>
                     </a:p>
                   </a:txBody>
-                  <a:tcPr marL="91440" marR="91440" marT="45720" marB="45720" anchor="ctr">
+                  <a:tcPr anchor="ctr">
                     <a:lnL w="6350" cap="flat" cmpd="sng" algn="ctr">
                       <a:solidFill>
                         <a:srgbClr val="B9C2C6"/>
@@ -9250,7 +9197,7 @@
                     <a:bodyPr/>
                     <a:lstStyle/>
                     <a:p>
-                      <a:pPr indent="0" marL="0">
+                      <a:pPr marL="0" indent="0">
                         <a:buNone/>
                       </a:pPr>
                       <a:r>
@@ -9271,7 +9218,7 @@
                       </a:endParaRPr>
                     </a:p>
                   </a:txBody>
-                  <a:tcPr marL="91440" marR="91440" marT="45720" marB="45720" anchor="ctr">
+                  <a:tcPr anchor="ctr">
                     <a:lnL w="6350" cap="flat" cmpd="sng" algn="ctr">
                       <a:solidFill>
                         <a:srgbClr val="B9C2C6"/>
@@ -9318,7 +9265,7 @@
                     <a:bodyPr/>
                     <a:lstStyle/>
                     <a:p>
-                      <a:pPr indent="0" marL="0">
+                      <a:pPr marL="0" indent="0">
                         <a:buNone/>
                       </a:pPr>
                       <a:r>
@@ -9339,7 +9286,7 @@
                       </a:endParaRPr>
                     </a:p>
                   </a:txBody>
-                  <a:tcPr marL="91440" marR="91440" marT="45720" marB="45720" anchor="ctr">
+                  <a:tcPr anchor="ctr">
                     <a:lnL w="6350" cap="flat" cmpd="sng" algn="ctr">
                       <a:solidFill>
                         <a:srgbClr val="B9C2C6"/>
@@ -9381,6 +9328,11 @@
                     </a:solidFill>
                   </a:tcPr>
                 </a:tc>
+                <a:extLst>
+                  <a:ext uri="{0D108BD9-81ED-4DB2-BD59-A6C34878D82A}">
+                    <a16:rowId xmlns:a16="http://schemas.microsoft.com/office/drawing/2014/main" val="10003"/>
+                  </a:ext>
+                </a:extLst>
               </a:tr>
               <a:tr h="274320">
                 <a:tc>
@@ -9388,7 +9340,7 @@
                     <a:bodyPr/>
                     <a:lstStyle/>
                     <a:p>
-                      <a:pPr indent="0" marL="0">
+                      <a:pPr marL="0" indent="0">
                         <a:buNone/>
                       </a:pPr>
                       <a:r>
@@ -9409,7 +9361,7 @@
                       </a:endParaRPr>
                     </a:p>
                   </a:txBody>
-                  <a:tcPr marL="91440" marR="91440" marT="45720" marB="45720" anchor="ctr">
+                  <a:tcPr anchor="ctr">
                     <a:lnL w="6350" cap="flat" cmpd="sng" algn="ctr">
                       <a:solidFill>
                         <a:srgbClr val="B9C2C6"/>
@@ -9456,7 +9408,7 @@
                     <a:bodyPr/>
                     <a:lstStyle/>
                     <a:p>
-                      <a:pPr indent="0" marL="0">
+                      <a:pPr marL="0" indent="0">
                         <a:buNone/>
                       </a:pPr>
                       <a:r>
@@ -9477,7 +9429,7 @@
                       </a:endParaRPr>
                     </a:p>
                   </a:txBody>
-                  <a:tcPr marL="91440" marR="91440" marT="45720" marB="45720" anchor="ctr">
+                  <a:tcPr anchor="ctr">
                     <a:lnL w="6350" cap="flat" cmpd="sng" algn="ctr">
                       <a:solidFill>
                         <a:srgbClr val="B9C2C6"/>
@@ -9524,7 +9476,7 @@
                     <a:bodyPr/>
                     <a:lstStyle/>
                     <a:p>
-                      <a:pPr indent="0" marL="0">
+                      <a:pPr marL="0" indent="0">
                         <a:buNone/>
                       </a:pPr>
                       <a:r>
@@ -9545,7 +9497,7 @@
                       </a:endParaRPr>
                     </a:p>
                   </a:txBody>
-                  <a:tcPr marL="91440" marR="91440" marT="45720" marB="45720" anchor="ctr">
+                  <a:tcPr anchor="ctr">
                     <a:lnL w="6350" cap="flat" cmpd="sng" algn="ctr">
                       <a:solidFill>
                         <a:srgbClr val="B9C2C6"/>
@@ -9587,6 +9539,11 @@
                     </a:solidFill>
                   </a:tcPr>
                 </a:tc>
+                <a:extLst>
+                  <a:ext uri="{0D108BD9-81ED-4DB2-BD59-A6C34878D82A}">
+                    <a16:rowId xmlns:a16="http://schemas.microsoft.com/office/drawing/2014/main" val="10004"/>
+                  </a:ext>
+                </a:extLst>
               </a:tr>
               <a:tr h="274320">
                 <a:tc>
@@ -9594,7 +9551,7 @@
                     <a:bodyPr/>
                     <a:lstStyle/>
                     <a:p>
-                      <a:pPr indent="0" marL="0">
+                      <a:pPr marL="0" indent="0">
                         <a:buNone/>
                       </a:pPr>
                       <a:r>
@@ -9615,7 +9572,7 @@
                       </a:endParaRPr>
                     </a:p>
                   </a:txBody>
-                  <a:tcPr marL="91440" marR="91440" marT="45720" marB="45720" anchor="ctr">
+                  <a:tcPr anchor="ctr">
                     <a:lnL w="6350" cap="flat" cmpd="sng" algn="ctr">
                       <a:solidFill>
                         <a:srgbClr val="B9C2C6"/>
@@ -9662,7 +9619,7 @@
                     <a:bodyPr/>
                     <a:lstStyle/>
                     <a:p>
-                      <a:pPr indent="0" marL="0">
+                      <a:pPr marL="0" indent="0">
                         <a:buNone/>
                       </a:pPr>
                       <a:r>
@@ -9683,7 +9640,7 @@
                       </a:endParaRPr>
                     </a:p>
                   </a:txBody>
-                  <a:tcPr marL="91440" marR="91440" marT="45720" marB="45720" anchor="ctr">
+                  <a:tcPr anchor="ctr">
                     <a:lnL w="6350" cap="flat" cmpd="sng" algn="ctr">
                       <a:solidFill>
                         <a:srgbClr val="B9C2C6"/>
@@ -9730,7 +9687,7 @@
                     <a:bodyPr/>
                     <a:lstStyle/>
                     <a:p>
-                      <a:pPr indent="0" marL="0">
+                      <a:pPr marL="0" indent="0">
                         <a:buNone/>
                       </a:pPr>
                       <a:r>
@@ -9751,7 +9708,7 @@
                       </a:endParaRPr>
                     </a:p>
                   </a:txBody>
-                  <a:tcPr marL="91440" marR="91440" marT="45720" marB="45720" anchor="ctr">
+                  <a:tcPr anchor="ctr">
                     <a:lnL w="6350" cap="flat" cmpd="sng" algn="ctr">
                       <a:solidFill>
                         <a:srgbClr val="B9C2C6"/>
@@ -9793,6 +9750,11 @@
                     </a:solidFill>
                   </a:tcPr>
                 </a:tc>
+                <a:extLst>
+                  <a:ext uri="{0D108BD9-81ED-4DB2-BD59-A6C34878D82A}">
+                    <a16:rowId xmlns:a16="http://schemas.microsoft.com/office/drawing/2014/main" val="10005"/>
+                  </a:ext>
+                </a:extLst>
               </a:tr>
             </a:tbl>
           </a:graphicData>
@@ -9819,7 +9781,7 @@
           <a:bodyPr wrap="square" lIns="0" tIns="0" rIns="0" bIns="0" rtlCol="0" anchor="ctr"/>
           <a:lstStyle/>
           <a:p>
-            <a:pPr indent="0" marL="0">
+            <a:pPr marL="0" indent="0">
               <a:buNone/>
             </a:pPr>
             <a:r>
@@ -9839,7 +9801,7 @@
       </p:sp>
       <p:sp>
         <p:nvSpPr>
-          <p:cNvPr id="6" name="Text 3"/>
+          <p:cNvPr id="4" name="Text 3"/>
           <p:cNvSpPr/>
           <p:nvPr/>
         </p:nvSpPr>
@@ -9858,7 +9820,7 @@
           <a:bodyPr wrap="square" lIns="0" tIns="0" rIns="0" bIns="0" rtlCol="0" anchor="ctr"/>
           <a:lstStyle/>
           <a:p>
-            <a:pPr indent="0" marL="0">
+            <a:pPr marL="0" indent="0">
               <a:buNone/>
             </a:pPr>
             <a:r>
@@ -9897,7 +9859,7 @@
           <a:bodyPr wrap="square" lIns="0" tIns="0" rIns="0" bIns="0" rtlCol="0" anchor="ctr"/>
           <a:lstStyle/>
           <a:p>
-            <a:pPr algn="r" indent="0" marL="0">
+            <a:pPr marL="0" indent="0" algn="r">
               <a:buNone/>
             </a:pPr>
             <a:r>
@@ -9931,6 +9893,7 @@
         <a:solidFill>
           <a:srgbClr val="091A23"/>
         </a:solidFill>
+        <a:effectLst/>
       </p:bgPr>
     </p:bg>
     <p:spTree>
@@ -9968,7 +9931,7 @@
           <a:bodyPr wrap="square" lIns="0" tIns="0" rIns="0" bIns="0" rtlCol="0" anchor="ctr"/>
           <a:lstStyle/>
           <a:p>
-            <a:pPr indent="0" marL="0">
+            <a:pPr marL="0" indent="0">
               <a:buNone/>
             </a:pPr>
             <a:r>
@@ -10007,7 +9970,7 @@
           <a:bodyPr wrap="square" lIns="0" tIns="0" rIns="0" bIns="0" rtlCol="0" anchor="ctr"/>
           <a:lstStyle/>
           <a:p>
-            <a:pPr indent="0" marL="0">
+            <a:pPr marL="0" indent="0">
               <a:buNone/>
             </a:pPr>
             <a:r>
@@ -10049,6 +10012,13 @@
             <a:prstDash val="solid"/>
           </a:ln>
         </p:spPr>
+        <p:txBody>
+          <a:bodyPr/>
+          <a:lstStyle/>
+          <a:p>
+            <a:endParaRPr lang="en-US"/>
+          </a:p>
+        </p:txBody>
       </p:sp>
       <p:sp>
         <p:nvSpPr>
@@ -10071,7 +10041,7 @@
           <a:bodyPr wrap="square" lIns="0" tIns="0" rIns="0" bIns="0" rtlCol="0" anchor="t"/>
           <a:lstStyle/>
           <a:p>
-            <a:pPr algn="l" indent="0" marL="0">
+            <a:pPr marL="0" indent="0" algn="l">
               <a:buNone/>
             </a:pPr>
             <a:r>
@@ -10088,7 +10058,7 @@
             <a:endParaRPr lang="en-US" sz="1150" dirty="0"/>
           </a:p>
           <a:p>
-            <a:pPr algn="l" indent="0" marL="0">
+            <a:pPr marL="0" indent="0" algn="l">
               <a:buNone/>
             </a:pPr>
             <a:r>
@@ -10105,13 +10075,13 @@
             <a:endParaRPr lang="en-US" sz="1150" dirty="0"/>
           </a:p>
           <a:p>
-            <a:pPr algn="l" indent="0" marL="0">
+            <a:pPr marL="0" indent="0" algn="l">
               <a:buNone/>
             </a:pPr>
             <a:endParaRPr lang="en-US" sz="1150" dirty="0"/>
           </a:p>
           <a:p>
-            <a:pPr algn="l" indent="0" marL="0">
+            <a:pPr marL="0" indent="0" algn="l">
               <a:buNone/>
             </a:pPr>
             <a:r>
@@ -10128,7 +10098,7 @@
             <a:endParaRPr lang="en-US" sz="1150" dirty="0"/>
           </a:p>
           <a:p>
-            <a:pPr algn="l" indent="0" marL="0">
+            <a:pPr marL="0" indent="0" algn="l">
               <a:buNone/>
             </a:pPr>
             <a:r>
@@ -10145,7 +10115,7 @@
             <a:endParaRPr lang="en-US" sz="1150" dirty="0"/>
           </a:p>
           <a:p>
-            <a:pPr algn="l" indent="0" marL="0">
+            <a:pPr marL="0" indent="0" algn="l">
               <a:buNone/>
             </a:pPr>
             <a:r>
@@ -10162,7 +10132,7 @@
             <a:endParaRPr lang="en-US" sz="1150" dirty="0"/>
           </a:p>
           <a:p>
-            <a:pPr algn="l" indent="0" marL="0">
+            <a:pPr marL="0" indent="0" algn="l">
               <a:buNone/>
             </a:pPr>
             <a:r>
@@ -10179,13 +10149,13 @@
             <a:endParaRPr lang="en-US" sz="1150" dirty="0"/>
           </a:p>
           <a:p>
-            <a:pPr algn="l" indent="0" marL="0">
+            <a:pPr marL="0" indent="0" algn="l">
               <a:buNone/>
             </a:pPr>
             <a:endParaRPr lang="en-US" sz="1150" dirty="0"/>
           </a:p>
           <a:p>
-            <a:pPr algn="l" indent="0" marL="0">
+            <a:pPr marL="0" indent="0" algn="l">
               <a:buNone/>
             </a:pPr>
             <a:r>
@@ -10202,7 +10172,7 @@
             <a:endParaRPr lang="en-US" sz="1150" dirty="0"/>
           </a:p>
           <a:p>
-            <a:pPr algn="l" indent="0" marL="0">
+            <a:pPr marL="0" indent="0" algn="l">
               <a:buNone/>
             </a:pPr>
             <a:r>
@@ -10219,7 +10189,7 @@
             <a:endParaRPr lang="en-US" sz="1150" dirty="0"/>
           </a:p>
           <a:p>
-            <a:pPr algn="l" indent="0" marL="0">
+            <a:pPr marL="0" indent="0" algn="l">
               <a:buNone/>
             </a:pPr>
             <a:r>
@@ -10236,7 +10206,7 @@
             <a:endParaRPr lang="en-US" sz="1150" dirty="0"/>
           </a:p>
           <a:p>
-            <a:pPr algn="l" indent="0" marL="0">
+            <a:pPr marL="0" indent="0" algn="l">
               <a:buNone/>
             </a:pPr>
             <a:r>
@@ -10275,7 +10245,7 @@
           <a:bodyPr wrap="square" lIns="0" tIns="0" rIns="0" bIns="0" rtlCol="0" anchor="ctr"/>
           <a:lstStyle/>
           <a:p>
-            <a:pPr indent="0" marL="0">
+            <a:pPr marL="0" indent="0">
               <a:buNone/>
             </a:pPr>
             <a:r>
@@ -10314,7 +10284,7 @@
           <a:bodyPr wrap="square" lIns="0" tIns="0" rIns="0" bIns="0" rtlCol="0" anchor="ctr"/>
           <a:lstStyle/>
           <a:p>
-            <a:pPr indent="0" marL="0">
+            <a:pPr marL="0" indent="0">
               <a:buNone/>
             </a:pPr>
             <a:r>
@@ -10353,7 +10323,7 @@
           <a:bodyPr wrap="square" lIns="0" tIns="0" rIns="0" bIns="0" rtlCol="0" anchor="ctr"/>
           <a:lstStyle/>
           <a:p>
-            <a:pPr algn="r" indent="0" marL="0">
+            <a:pPr marL="0" indent="0" algn="r">
               <a:buNone/>
             </a:pPr>
             <a:r>
@@ -10387,6 +10357,7 @@
         <a:solidFill>
           <a:srgbClr val="FFFFFF"/>
         </a:solidFill>
+        <a:effectLst/>
       </p:bgPr>
     </p:bg>
     <p:spTree>
@@ -10424,7 +10395,7 @@
           <a:bodyPr wrap="square" lIns="0" tIns="0" rIns="0" bIns="0" rtlCol="0" anchor="ctr"/>
           <a:lstStyle/>
           <a:p>
-            <a:pPr indent="0" marL="0">
+            <a:pPr marL="0" indent="0">
               <a:buNone/>
             </a:pPr>
             <a:r>
@@ -10463,7 +10434,7 @@
           <a:bodyPr wrap="square" lIns="0" tIns="0" rIns="0" bIns="0" rtlCol="0" anchor="ctr"/>
           <a:lstStyle/>
           <a:p>
-            <a:pPr indent="0" marL="0">
+            <a:pPr marL="0" indent="0">
               <a:buNone/>
             </a:pPr>
             <a:r>
@@ -10502,7 +10473,7 @@
           <a:bodyPr wrap="square" lIns="0" tIns="0" rIns="0" bIns="0" rtlCol="0" anchor="ctr"/>
           <a:lstStyle/>
           <a:p>
-            <a:pPr indent="0" marL="0">
+            <a:pPr marL="0" indent="0">
               <a:buNone/>
             </a:pPr>
             <a:r>
@@ -10528,7 +10499,7 @@
         </p:nvSpPr>
         <p:spPr>
           <a:xfrm>
-            <a:off x="384048" y="1444752"/>
+            <a:off x="384048" y="1591056"/>
             <a:ext cx="8412480" cy="256032"/>
           </a:xfrm>
           <a:prstGeom prst="rect">
@@ -10541,7 +10512,7 @@
           <a:bodyPr wrap="square" lIns="0" tIns="0" rIns="0" bIns="0" rtlCol="0" anchor="ctr"/>
           <a:lstStyle/>
           <a:p>
-            <a:pPr indent="0" marL="0">
+            <a:pPr marL="0" indent="0">
               <a:buNone/>
             </a:pPr>
             <a:r>
@@ -10656,7 +10627,7 @@
           <a:bodyPr wrap="square" lIns="0" tIns="0" rIns="0" bIns="0" rtlCol="0" anchor="ctr"/>
           <a:lstStyle/>
           <a:p>
-            <a:pPr indent="0" marL="0">
+            <a:pPr marL="0" indent="0">
               <a:buNone/>
             </a:pPr>
             <a:r>
@@ -10695,7 +10666,7 @@
           <a:bodyPr wrap="square" lIns="0" tIns="0" rIns="0" bIns="0" rtlCol="0" anchor="ctr"/>
           <a:lstStyle/>
           <a:p>
-            <a:pPr indent="0" marL="0">
+            <a:pPr marL="0" indent="0">
               <a:buNone/>
             </a:pPr>
             <a:r>
@@ -10734,7 +10705,7 @@
           <a:bodyPr wrap="square" lIns="0" tIns="0" rIns="0" bIns="0" rtlCol="0" anchor="ctr"/>
           <a:lstStyle/>
           <a:p>
-            <a:pPr algn="r" indent="0" marL="0">
+            <a:pPr marL="0" indent="0" algn="r">
               <a:buNone/>
             </a:pPr>
             <a:r>
@@ -10768,6 +10739,7 @@
         <a:solidFill>
           <a:srgbClr val="FFFFFF"/>
         </a:solidFill>
+        <a:effectLst/>
       </p:bgPr>
     </p:bg>
     <p:spTree>
@@ -10805,7 +10777,7 @@
           <a:bodyPr wrap="square" lIns="0" tIns="0" rIns="0" bIns="0" rtlCol="0" anchor="ctr"/>
           <a:lstStyle/>
           <a:p>
-            <a:pPr indent="0" marL="0">
+            <a:pPr marL="0" indent="0">
               <a:buNone/>
             </a:pPr>
             <a:r>
@@ -10844,7 +10816,7 @@
           <a:bodyPr wrap="square" lIns="0" tIns="0" rIns="0" bIns="0" rtlCol="0" anchor="ctr"/>
           <a:lstStyle/>
           <a:p>
-            <a:pPr indent="0" marL="0">
+            <a:pPr marL="0" indent="0">
               <a:buNone/>
             </a:pPr>
             <a:r>
@@ -10878,16 +10850,34 @@
         </p:nvGraphicFramePr>
         <p:xfrm>
           <a:off x="384048" y="1078992"/>
-          <a:ext cx="8412480" cy="914400"/>
+          <a:ext cx="8412480" cy="1859280"/>
         </p:xfrm>
         <a:graphic>
           <a:graphicData uri="http://schemas.openxmlformats.org/drawingml/2006/table">
             <a:tbl>
               <a:tblPr/>
               <a:tblGrid>
-                <a:gridCol w="1828800"/>
-                <a:gridCol w="3291840"/>
-                <a:gridCol w="3291840"/>
+                <a:gridCol w="1828800">
+                  <a:extLst>
+                    <a:ext uri="{9D8B030D-6E8A-4147-A177-3AD203B41FA5}">
+                      <a16:colId xmlns:a16="http://schemas.microsoft.com/office/drawing/2014/main" val="20000"/>
+                    </a:ext>
+                  </a:extLst>
+                </a:gridCol>
+                <a:gridCol w="3291840">
+                  <a:extLst>
+                    <a:ext uri="{9D8B030D-6E8A-4147-A177-3AD203B41FA5}">
+                      <a16:colId xmlns:a16="http://schemas.microsoft.com/office/drawing/2014/main" val="20001"/>
+                    </a:ext>
+                  </a:extLst>
+                </a:gridCol>
+                <a:gridCol w="3291840">
+                  <a:extLst>
+                    <a:ext uri="{9D8B030D-6E8A-4147-A177-3AD203B41FA5}">
+                      <a16:colId xmlns:a16="http://schemas.microsoft.com/office/drawing/2014/main" val="20002"/>
+                    </a:ext>
+                  </a:extLst>
+                </a:gridCol>
               </a:tblGrid>
               <a:tr h="274320">
                 <a:tc>
@@ -10895,7 +10885,7 @@
                     <a:bodyPr/>
                     <a:lstStyle/>
                     <a:p>
-                      <a:pPr indent="0" marL="0">
+                      <a:pPr marL="0" indent="0">
                         <a:buNone/>
                       </a:pPr>
                       <a:endParaRPr lang="en-US" sz="1000" dirty="0">
@@ -10905,7 +10895,7 @@
                       </a:endParaRPr>
                     </a:p>
                   </a:txBody>
-                  <a:tcPr marL="91440" marR="91440" marT="45720" marB="45720" anchor="ctr">
+                  <a:tcPr anchor="ctr">
                     <a:lnL w="6350" cap="flat" cmpd="sng" algn="ctr">
                       <a:solidFill>
                         <a:srgbClr val="B9C2C6"/>
@@ -10952,7 +10942,7 @@
                     <a:bodyPr/>
                     <a:lstStyle/>
                     <a:p>
-                      <a:pPr indent="0" marL="0">
+                      <a:pPr marL="0" indent="0">
                         <a:buNone/>
                       </a:pPr>
                       <a:r>
@@ -10973,7 +10963,7 @@
                       </a:endParaRPr>
                     </a:p>
                   </a:txBody>
-                  <a:tcPr marL="91440" marR="91440" marT="45720" marB="45720" anchor="ctr">
+                  <a:tcPr anchor="ctr">
                     <a:lnL w="6350" cap="flat" cmpd="sng" algn="ctr">
                       <a:solidFill>
                         <a:srgbClr val="B9C2C6"/>
@@ -11020,7 +11010,7 @@
                     <a:bodyPr/>
                     <a:lstStyle/>
                     <a:p>
-                      <a:pPr indent="0" marL="0">
+                      <a:pPr marL="0" indent="0">
                         <a:buNone/>
                       </a:pPr>
                       <a:r>
@@ -11041,7 +11031,7 @@
                       </a:endParaRPr>
                     </a:p>
                   </a:txBody>
-                  <a:tcPr marL="91440" marR="91440" marT="45720" marB="45720" anchor="ctr">
+                  <a:tcPr anchor="ctr">
                     <a:lnL w="6350" cap="flat" cmpd="sng" algn="ctr">
                       <a:solidFill>
                         <a:srgbClr val="B9C2C6"/>
@@ -11083,6 +11073,11 @@
                     </a:solidFill>
                   </a:tcPr>
                 </a:tc>
+                <a:extLst>
+                  <a:ext uri="{0D108BD9-81ED-4DB2-BD59-A6C34878D82A}">
+                    <a16:rowId xmlns:a16="http://schemas.microsoft.com/office/drawing/2014/main" val="10000"/>
+                  </a:ext>
+                </a:extLst>
               </a:tr>
               <a:tr h="274320">
                 <a:tc>
@@ -11090,7 +11085,7 @@
                     <a:bodyPr/>
                     <a:lstStyle/>
                     <a:p>
-                      <a:pPr indent="0" marL="0">
+                      <a:pPr marL="0" indent="0">
                         <a:buNone/>
                       </a:pPr>
                       <a:r>
@@ -11111,7 +11106,7 @@
                       </a:endParaRPr>
                     </a:p>
                   </a:txBody>
-                  <a:tcPr marL="91440" marR="91440" marT="45720" marB="45720" anchor="ctr">
+                  <a:tcPr anchor="ctr">
                     <a:lnL w="6350" cap="flat" cmpd="sng" algn="ctr">
                       <a:solidFill>
                         <a:srgbClr val="B9C2C6"/>
@@ -11158,7 +11153,7 @@
                     <a:bodyPr/>
                     <a:lstStyle/>
                     <a:p>
-                      <a:pPr indent="0" marL="0">
+                      <a:pPr marL="0" indent="0">
                         <a:buNone/>
                       </a:pPr>
                       <a:r>
@@ -11179,7 +11174,7 @@
                       </a:endParaRPr>
                     </a:p>
                   </a:txBody>
-                  <a:tcPr marL="91440" marR="91440" marT="45720" marB="45720" anchor="ctr">
+                  <a:tcPr anchor="ctr">
                     <a:lnL w="6350" cap="flat" cmpd="sng" algn="ctr">
                       <a:solidFill>
                         <a:srgbClr val="B9C2C6"/>
@@ -11226,7 +11221,7 @@
                     <a:bodyPr/>
                     <a:lstStyle/>
                     <a:p>
-                      <a:pPr indent="0" marL="0">
+                      <a:pPr marL="0" indent="0">
                         <a:buNone/>
                       </a:pPr>
                       <a:r>
@@ -11247,7 +11242,7 @@
                       </a:endParaRPr>
                     </a:p>
                   </a:txBody>
-                  <a:tcPr marL="91440" marR="91440" marT="45720" marB="45720" anchor="ctr">
+                  <a:tcPr anchor="ctr">
                     <a:lnL w="6350" cap="flat" cmpd="sng" algn="ctr">
                       <a:solidFill>
                         <a:srgbClr val="B9C2C6"/>
@@ -11289,6 +11284,11 @@
                     </a:solidFill>
                   </a:tcPr>
                 </a:tc>
+                <a:extLst>
+                  <a:ext uri="{0D108BD9-81ED-4DB2-BD59-A6C34878D82A}">
+                    <a16:rowId xmlns:a16="http://schemas.microsoft.com/office/drawing/2014/main" val="10001"/>
+                  </a:ext>
+                </a:extLst>
               </a:tr>
               <a:tr h="274320">
                 <a:tc>
@@ -11296,7 +11296,7 @@
                     <a:bodyPr/>
                     <a:lstStyle/>
                     <a:p>
-                      <a:pPr indent="0" marL="0">
+                      <a:pPr marL="0" indent="0">
                         <a:buNone/>
                       </a:pPr>
                       <a:r>
@@ -11317,7 +11317,7 @@
                       </a:endParaRPr>
                     </a:p>
                   </a:txBody>
-                  <a:tcPr marL="91440" marR="91440" marT="45720" marB="45720" anchor="ctr">
+                  <a:tcPr anchor="ctr">
                     <a:lnL w="6350" cap="flat" cmpd="sng" algn="ctr">
                       <a:solidFill>
                         <a:srgbClr val="B9C2C6"/>
@@ -11364,7 +11364,7 @@
                     <a:bodyPr/>
                     <a:lstStyle/>
                     <a:p>
-                      <a:pPr indent="0" marL="0">
+                      <a:pPr marL="0" indent="0">
                         <a:buNone/>
                       </a:pPr>
                       <a:r>
@@ -11385,7 +11385,7 @@
                       </a:endParaRPr>
                     </a:p>
                   </a:txBody>
-                  <a:tcPr marL="91440" marR="91440" marT="45720" marB="45720" anchor="ctr">
+                  <a:tcPr anchor="ctr">
                     <a:lnL w="6350" cap="flat" cmpd="sng" algn="ctr">
                       <a:solidFill>
                         <a:srgbClr val="B9C2C6"/>
@@ -11432,7 +11432,7 @@
                     <a:bodyPr/>
                     <a:lstStyle/>
                     <a:p>
-                      <a:pPr indent="0" marL="0">
+                      <a:pPr marL="0" indent="0">
                         <a:buNone/>
                       </a:pPr>
                       <a:r>
@@ -11453,7 +11453,7 @@
                       </a:endParaRPr>
                     </a:p>
                   </a:txBody>
-                  <a:tcPr marL="91440" marR="91440" marT="45720" marB="45720" anchor="ctr">
+                  <a:tcPr anchor="ctr">
                     <a:lnL w="6350" cap="flat" cmpd="sng" algn="ctr">
                       <a:solidFill>
                         <a:srgbClr val="B9C2C6"/>
@@ -11495,6 +11495,11 @@
                     </a:solidFill>
                   </a:tcPr>
                 </a:tc>
+                <a:extLst>
+                  <a:ext uri="{0D108BD9-81ED-4DB2-BD59-A6C34878D82A}">
+                    <a16:rowId xmlns:a16="http://schemas.microsoft.com/office/drawing/2014/main" val="10002"/>
+                  </a:ext>
+                </a:extLst>
               </a:tr>
               <a:tr h="274320">
                 <a:tc>
@@ -11502,7 +11507,7 @@
                     <a:bodyPr/>
                     <a:lstStyle/>
                     <a:p>
-                      <a:pPr indent="0" marL="0">
+                      <a:pPr marL="0" indent="0">
                         <a:buNone/>
                       </a:pPr>
                       <a:r>
@@ -11523,7 +11528,7 @@
                       </a:endParaRPr>
                     </a:p>
                   </a:txBody>
-                  <a:tcPr marL="91440" marR="91440" marT="45720" marB="45720" anchor="ctr">
+                  <a:tcPr anchor="ctr">
                     <a:lnL w="6350" cap="flat" cmpd="sng" algn="ctr">
                       <a:solidFill>
                         <a:srgbClr val="B9C2C6"/>
@@ -11570,7 +11575,7 @@
                     <a:bodyPr/>
                     <a:lstStyle/>
                     <a:p>
-                      <a:pPr indent="0" marL="0">
+                      <a:pPr marL="0" indent="0">
                         <a:buNone/>
                       </a:pPr>
                       <a:r>
@@ -11591,7 +11596,7 @@
                       </a:endParaRPr>
                     </a:p>
                   </a:txBody>
-                  <a:tcPr marL="91440" marR="91440" marT="45720" marB="45720" anchor="ctr">
+                  <a:tcPr anchor="ctr">
                     <a:lnL w="6350" cap="flat" cmpd="sng" algn="ctr">
                       <a:solidFill>
                         <a:srgbClr val="B9C2C6"/>
@@ -11638,7 +11643,7 @@
                     <a:bodyPr/>
                     <a:lstStyle/>
                     <a:p>
-                      <a:pPr indent="0" marL="0">
+                      <a:pPr marL="0" indent="0">
                         <a:buNone/>
                       </a:pPr>
                       <a:r>
@@ -11659,7 +11664,7 @@
                       </a:endParaRPr>
                     </a:p>
                   </a:txBody>
-                  <a:tcPr marL="91440" marR="91440" marT="45720" marB="45720" anchor="ctr">
+                  <a:tcPr anchor="ctr">
                     <a:lnL w="6350" cap="flat" cmpd="sng" algn="ctr">
                       <a:solidFill>
                         <a:srgbClr val="B9C2C6"/>
@@ -11701,6 +11706,11 @@
                     </a:solidFill>
                   </a:tcPr>
                 </a:tc>
+                <a:extLst>
+                  <a:ext uri="{0D108BD9-81ED-4DB2-BD59-A6C34878D82A}">
+                    <a16:rowId xmlns:a16="http://schemas.microsoft.com/office/drawing/2014/main" val="10003"/>
+                  </a:ext>
+                </a:extLst>
               </a:tr>
               <a:tr h="274320">
                 <a:tc>
@@ -11708,7 +11718,7 @@
                     <a:bodyPr/>
                     <a:lstStyle/>
                     <a:p>
-                      <a:pPr indent="0" marL="0">
+                      <a:pPr marL="0" indent="0">
                         <a:buNone/>
                       </a:pPr>
                       <a:r>
@@ -11729,7 +11739,7 @@
                       </a:endParaRPr>
                     </a:p>
                   </a:txBody>
-                  <a:tcPr marL="91440" marR="91440" marT="45720" marB="45720" anchor="ctr">
+                  <a:tcPr anchor="ctr">
                     <a:lnL w="6350" cap="flat" cmpd="sng" algn="ctr">
                       <a:solidFill>
                         <a:srgbClr val="B9C2C6"/>
@@ -11776,7 +11786,7 @@
                     <a:bodyPr/>
                     <a:lstStyle/>
                     <a:p>
-                      <a:pPr indent="0" marL="0">
+                      <a:pPr marL="0" indent="0">
                         <a:buNone/>
                       </a:pPr>
                       <a:r>
@@ -11797,7 +11807,7 @@
                       </a:endParaRPr>
                     </a:p>
                   </a:txBody>
-                  <a:tcPr marL="91440" marR="91440" marT="45720" marB="45720" anchor="ctr">
+                  <a:tcPr anchor="ctr">
                     <a:lnL w="6350" cap="flat" cmpd="sng" algn="ctr">
                       <a:solidFill>
                         <a:srgbClr val="B9C2C6"/>
@@ -11844,7 +11854,7 @@
                     <a:bodyPr/>
                     <a:lstStyle/>
                     <a:p>
-                      <a:pPr indent="0" marL="0">
+                      <a:pPr marL="0" indent="0">
                         <a:buNone/>
                       </a:pPr>
                       <a:r>
@@ -11865,7 +11875,7 @@
                       </a:endParaRPr>
                     </a:p>
                   </a:txBody>
-                  <a:tcPr marL="91440" marR="91440" marT="45720" marB="45720" anchor="ctr">
+                  <a:tcPr anchor="ctr">
                     <a:lnL w="6350" cap="flat" cmpd="sng" algn="ctr">
                       <a:solidFill>
                         <a:srgbClr val="B9C2C6"/>
@@ -11907,6 +11917,11 @@
                     </a:solidFill>
                   </a:tcPr>
                 </a:tc>
+                <a:extLst>
+                  <a:ext uri="{0D108BD9-81ED-4DB2-BD59-A6C34878D82A}">
+                    <a16:rowId xmlns:a16="http://schemas.microsoft.com/office/drawing/2014/main" val="10004"/>
+                  </a:ext>
+                </a:extLst>
               </a:tr>
               <a:tr h="274320">
                 <a:tc>
@@ -11914,7 +11929,7 @@
                     <a:bodyPr/>
                     <a:lstStyle/>
                     <a:p>
-                      <a:pPr indent="0" marL="0">
+                      <a:pPr marL="0" indent="0">
                         <a:buNone/>
                       </a:pPr>
                       <a:r>
@@ -11935,7 +11950,7 @@
                       </a:endParaRPr>
                     </a:p>
                   </a:txBody>
-                  <a:tcPr marL="91440" marR="91440" marT="45720" marB="45720" anchor="ctr">
+                  <a:tcPr anchor="ctr">
                     <a:lnL w="6350" cap="flat" cmpd="sng" algn="ctr">
                       <a:solidFill>
                         <a:srgbClr val="B9C2C6"/>
@@ -11982,7 +11997,7 @@
                     <a:bodyPr/>
                     <a:lstStyle/>
                     <a:p>
-                      <a:pPr indent="0" marL="0">
+                      <a:pPr marL="0" indent="0">
                         <a:buNone/>
                       </a:pPr>
                       <a:r>
@@ -12003,7 +12018,7 @@
                       </a:endParaRPr>
                     </a:p>
                   </a:txBody>
-                  <a:tcPr marL="91440" marR="91440" marT="45720" marB="45720" anchor="ctr">
+                  <a:tcPr anchor="ctr">
                     <a:lnL w="6350" cap="flat" cmpd="sng" algn="ctr">
                       <a:solidFill>
                         <a:srgbClr val="B9C2C6"/>
@@ -12050,7 +12065,7 @@
                     <a:bodyPr/>
                     <a:lstStyle/>
                     <a:p>
-                      <a:pPr indent="0" marL="0">
+                      <a:pPr marL="0" indent="0">
                         <a:buNone/>
                       </a:pPr>
                       <a:r>
@@ -12071,7 +12086,7 @@
                       </a:endParaRPr>
                     </a:p>
                   </a:txBody>
-                  <a:tcPr marL="91440" marR="91440" marT="45720" marB="45720" anchor="ctr">
+                  <a:tcPr anchor="ctr">
                     <a:lnL w="6350" cap="flat" cmpd="sng" algn="ctr">
                       <a:solidFill>
                         <a:srgbClr val="B9C2C6"/>
@@ -12113,6 +12128,11 @@
                     </a:solidFill>
                   </a:tcPr>
                 </a:tc>
+                <a:extLst>
+                  <a:ext uri="{0D108BD9-81ED-4DB2-BD59-A6C34878D82A}">
+                    <a16:rowId xmlns:a16="http://schemas.microsoft.com/office/drawing/2014/main" val="10005"/>
+                  </a:ext>
+                </a:extLst>
               </a:tr>
             </a:tbl>
           </a:graphicData>
@@ -12139,7 +12159,7 @@
           <a:bodyPr wrap="square" lIns="0" tIns="0" rIns="0" bIns="0" rtlCol="0" anchor="ctr"/>
           <a:lstStyle/>
           <a:p>
-            <a:pPr indent="0" marL="0">
+            <a:pPr marL="0" indent="0">
               <a:buNone/>
             </a:pPr>
             <a:r>
@@ -12178,7 +12198,7 @@
           <a:bodyPr wrap="square" lIns="0" tIns="0" rIns="0" bIns="0" rtlCol="0" anchor="ctr"/>
           <a:lstStyle/>
           <a:p>
-            <a:pPr indent="0" marL="0">
+            <a:pPr marL="0" indent="0">
               <a:buNone/>
             </a:pPr>
             <a:r>
@@ -12217,7 +12237,7 @@
           <a:bodyPr wrap="square" lIns="0" tIns="0" rIns="0" bIns="0" rtlCol="0" anchor="ctr"/>
           <a:lstStyle/>
           <a:p>
-            <a:pPr algn="r" indent="0" marL="0">
+            <a:pPr marL="0" indent="0" algn="r">
               <a:buNone/>
             </a:pPr>
             <a:r>
@@ -12251,6 +12271,7 @@
         <a:solidFill>
           <a:srgbClr val="091A23"/>
         </a:solidFill>
+        <a:effectLst/>
       </p:bgPr>
     </p:bg>
     <p:spTree>
@@ -12288,7 +12309,7 @@
           <a:bodyPr wrap="square" lIns="0" tIns="0" rIns="0" bIns="0" rtlCol="0" anchor="ctr"/>
           <a:lstStyle/>
           <a:p>
-            <a:pPr indent="0" marL="0">
+            <a:pPr marL="0" indent="0">
               <a:buNone/>
             </a:pPr>
             <a:r>
@@ -12327,7 +12348,7 @@
           <a:bodyPr wrap="square" lIns="0" tIns="0" rIns="0" bIns="0" rtlCol="0" anchor="ctr"/>
           <a:lstStyle/>
           <a:p>
-            <a:pPr indent="0" marL="0">
+            <a:pPr marL="0" indent="0">
               <a:buNone/>
             </a:pPr>
             <a:r>
@@ -12369,6 +12390,13 @@
             <a:prstDash val="solid"/>
           </a:ln>
         </p:spPr>
+        <p:txBody>
+          <a:bodyPr/>
+          <a:lstStyle/>
+          <a:p>
+            <a:endParaRPr lang="en-US"/>
+          </a:p>
+        </p:txBody>
       </p:sp>
       <p:sp>
         <p:nvSpPr>
@@ -12391,7 +12419,7 @@
           <a:bodyPr wrap="square" lIns="0" tIns="0" rIns="0" bIns="0" rtlCol="0" anchor="t"/>
           <a:lstStyle/>
           <a:p>
-            <a:pPr algn="l" indent="0" marL="0">
+            <a:pPr marL="0" indent="0" algn="l">
               <a:buNone/>
             </a:pPr>
             <a:r>
@@ -12408,7 +12436,7 @@
             <a:endParaRPr lang="en-US" sz="1150" dirty="0"/>
           </a:p>
           <a:p>
-            <a:pPr algn="l" indent="0" marL="0">
+            <a:pPr marL="0" indent="0" algn="l">
               <a:buNone/>
             </a:pPr>
             <a:r>
@@ -12425,7 +12453,7 @@
             <a:endParaRPr lang="en-US" sz="1150" dirty="0"/>
           </a:p>
           <a:p>
-            <a:pPr algn="l" indent="0" marL="0">
+            <a:pPr marL="0" indent="0" algn="l">
               <a:buNone/>
             </a:pPr>
             <a:r>
@@ -12442,7 +12470,7 @@
             <a:endParaRPr lang="en-US" sz="1150" dirty="0"/>
           </a:p>
           <a:p>
-            <a:pPr algn="l" indent="0" marL="0">
+            <a:pPr marL="0" indent="0" algn="l">
               <a:buNone/>
             </a:pPr>
             <a:r>
@@ -12459,7 +12487,7 @@
             <a:endParaRPr lang="en-US" sz="1150" dirty="0"/>
           </a:p>
           <a:p>
-            <a:pPr algn="l" indent="0" marL="0">
+            <a:pPr marL="0" indent="0" algn="l">
               <a:buNone/>
             </a:pPr>
             <a:r>
@@ -12476,7 +12504,7 @@
             <a:endParaRPr lang="en-US" sz="1150" dirty="0"/>
           </a:p>
           <a:p>
-            <a:pPr algn="l" indent="0" marL="0">
+            <a:pPr marL="0" indent="0" algn="l">
               <a:buNone/>
             </a:pPr>
             <a:r>
@@ -12493,7 +12521,7 @@
             <a:endParaRPr lang="en-US" sz="1150" dirty="0"/>
           </a:p>
           <a:p>
-            <a:pPr algn="l" indent="0" marL="0">
+            <a:pPr marL="0" indent="0" algn="l">
               <a:buNone/>
             </a:pPr>
             <a:r>
@@ -12510,7 +12538,7 @@
             <a:endParaRPr lang="en-US" sz="1150" dirty="0"/>
           </a:p>
           <a:p>
-            <a:pPr algn="l" indent="0" marL="0">
+            <a:pPr marL="0" indent="0" algn="l">
               <a:buNone/>
             </a:pPr>
             <a:r>
@@ -12549,7 +12577,7 @@
           <a:bodyPr wrap="square" lIns="0" tIns="0" rIns="0" bIns="0" rtlCol="0" anchor="ctr"/>
           <a:lstStyle/>
           <a:p>
-            <a:pPr indent="0" marL="0">
+            <a:pPr marL="0" indent="0">
               <a:buNone/>
             </a:pPr>
             <a:r>
@@ -12588,7 +12616,7 @@
           <a:bodyPr wrap="square" lIns="0" tIns="0" rIns="0" bIns="0" rtlCol="0" anchor="ctr"/>
           <a:lstStyle/>
           <a:p>
-            <a:pPr indent="0" marL="0">
+            <a:pPr marL="0" indent="0">
               <a:buNone/>
             </a:pPr>
             <a:r>
@@ -12627,7 +12655,7 @@
           <a:bodyPr wrap="square" lIns="0" tIns="0" rIns="0" bIns="0" rtlCol="0" anchor="ctr"/>
           <a:lstStyle/>
           <a:p>
-            <a:pPr algn="r" indent="0" marL="0">
+            <a:pPr marL="0" indent="0" algn="r">
               <a:buNone/>
             </a:pPr>
             <a:r>
@@ -12946,4 +12974,319 @@
     </a:ext>
   </a:extLst>
 </a:theme>
+</file>
+
+<file path=ppt/theme/theme2.xml><?xml version="1.0" encoding="utf-8"?>
+<a:theme xmlns:a="http://schemas.openxmlformats.org/drawingml/2006/main" name="Office Theme">
+  <a:themeElements>
+    <a:clrScheme name="Office">
+      <a:dk1>
+        <a:sysClr val="windowText" lastClr="000000"/>
+      </a:dk1>
+      <a:lt1>
+        <a:sysClr val="window" lastClr="FFFFFF"/>
+      </a:lt1>
+      <a:dk2>
+        <a:srgbClr val="0E2841"/>
+      </a:dk2>
+      <a:lt2>
+        <a:srgbClr val="E8E8E8"/>
+      </a:lt2>
+      <a:accent1>
+        <a:srgbClr val="156082"/>
+      </a:accent1>
+      <a:accent2>
+        <a:srgbClr val="E97132"/>
+      </a:accent2>
+      <a:accent3>
+        <a:srgbClr val="196B24"/>
+      </a:accent3>
+      <a:accent4>
+        <a:srgbClr val="0F9ED5"/>
+      </a:accent4>
+      <a:accent5>
+        <a:srgbClr val="A02B93"/>
+      </a:accent5>
+      <a:accent6>
+        <a:srgbClr val="4EA72E"/>
+      </a:accent6>
+      <a:hlink>
+        <a:srgbClr val="467886"/>
+      </a:hlink>
+      <a:folHlink>
+        <a:srgbClr val="96607D"/>
+      </a:folHlink>
+    </a:clrScheme>
+    <a:fontScheme name="Office">
+      <a:majorFont>
+        <a:latin typeface="Aptos Display" panose="02110004020202020204"/>
+        <a:ea typeface=""/>
+        <a:cs typeface=""/>
+        <a:font script="Jpan" typeface="游ゴシック Light"/>
+        <a:font script="Hang" typeface="맑은 고딕"/>
+        <a:font script="Hans" typeface="等线 Light"/>
+        <a:font script="Hant" typeface="新細明體"/>
+        <a:font script="Arab" typeface="Times New Roman"/>
+        <a:font script="Hebr" typeface="Times New Roman"/>
+        <a:font script="Thai" typeface="Angsana New"/>
+        <a:font script="Ethi" typeface="Nyala"/>
+        <a:font script="Beng" typeface="Vrinda"/>
+        <a:font script="Gujr" typeface="Shruti"/>
+        <a:font script="Khmr" typeface="MoolBoran"/>
+        <a:font script="Knda" typeface="Tunga"/>
+        <a:font script="Guru" typeface="Raavi"/>
+        <a:font script="Cans" typeface="Euphemia"/>
+        <a:font script="Cher" typeface="Plantagenet Cherokee"/>
+        <a:font script="Yiii" typeface="Microsoft Yi Baiti"/>
+        <a:font script="Tibt" typeface="Microsoft Himalaya"/>
+        <a:font script="Thaa" typeface="MV Boli"/>
+        <a:font script="Deva" typeface="Mangal"/>
+        <a:font script="Telu" typeface="Gautami"/>
+        <a:font script="Taml" typeface="Latha"/>
+        <a:font script="Syrc" typeface="Estrangelo Edessa"/>
+        <a:font script="Orya" typeface="Kalinga"/>
+        <a:font script="Mlym" typeface="Kartika"/>
+        <a:font script="Laoo" typeface="DokChampa"/>
+        <a:font script="Sinh" typeface="Iskoola Pota"/>
+        <a:font script="Mong" typeface="Mongolian Baiti"/>
+        <a:font script="Viet" typeface="Times New Roman"/>
+        <a:font script="Uigh" typeface="Microsoft Uighur"/>
+        <a:font script="Geor" typeface="Sylfaen"/>
+        <a:font script="Armn" typeface="Arial"/>
+        <a:font script="Bugi" typeface="Leelawadee UI"/>
+        <a:font script="Bopo" typeface="Microsoft JhengHei"/>
+        <a:font script="Java" typeface="Javanese Text"/>
+        <a:font script="Lisu" typeface="Segoe UI"/>
+        <a:font script="Mymr" typeface="Myanmar Text"/>
+        <a:font script="Nkoo" typeface="Ebrima"/>
+        <a:font script="Olck" typeface="Nirmala UI"/>
+        <a:font script="Osma" typeface="Ebrima"/>
+        <a:font script="Phag" typeface="Phagspa"/>
+        <a:font script="Syrn" typeface="Estrangelo Edessa"/>
+        <a:font script="Syrj" typeface="Estrangelo Edessa"/>
+        <a:font script="Syre" typeface="Estrangelo Edessa"/>
+        <a:font script="Sora" typeface="Nirmala UI"/>
+        <a:font script="Tale" typeface="Microsoft Tai Le"/>
+        <a:font script="Talu" typeface="Microsoft New Tai Lue"/>
+        <a:font script="Tfng" typeface="Ebrima"/>
+      </a:majorFont>
+      <a:minorFont>
+        <a:latin typeface="Aptos" panose="02110004020202020204"/>
+        <a:ea typeface=""/>
+        <a:cs typeface=""/>
+        <a:font script="Jpan" typeface="游ゴシック"/>
+        <a:font script="Hang" typeface="맑은 고딕"/>
+        <a:font script="Hans" typeface="等线"/>
+        <a:font script="Hant" typeface="新細明體"/>
+        <a:font script="Arab" typeface="Arial"/>
+        <a:font script="Hebr" typeface="Arial"/>
+        <a:font script="Thai" typeface="Cordia New"/>
+        <a:font script="Ethi" typeface="Nyala"/>
+        <a:font script="Beng" typeface="Vrinda"/>
+        <a:font script="Gujr" typeface="Shruti"/>
+        <a:font script="Khmr" typeface="DaunPenh"/>
+        <a:font script="Knda" typeface="Tunga"/>
+        <a:font script="Guru" typeface="Raavi"/>
+        <a:font script="Cans" typeface="Euphemia"/>
+        <a:font script="Cher" typeface="Plantagenet Cherokee"/>
+        <a:font script="Yiii" typeface="Microsoft Yi Baiti"/>
+        <a:font script="Tibt" typeface="Microsoft Himalaya"/>
+        <a:font script="Thaa" typeface="MV Boli"/>
+        <a:font script="Deva" typeface="Mangal"/>
+        <a:font script="Telu" typeface="Gautami"/>
+        <a:font script="Taml" typeface="Latha"/>
+        <a:font script="Syrc" typeface="Estrangelo Edessa"/>
+        <a:font script="Orya" typeface="Kalinga"/>
+        <a:font script="Mlym" typeface="Kartika"/>
+        <a:font script="Laoo" typeface="DokChampa"/>
+        <a:font script="Sinh" typeface="Iskoola Pota"/>
+        <a:font script="Mong" typeface="Mongolian Baiti"/>
+        <a:font script="Viet" typeface="Arial"/>
+        <a:font script="Uigh" typeface="Microsoft Uighur"/>
+        <a:font script="Geor" typeface="Sylfaen"/>
+        <a:font script="Armn" typeface="Arial"/>
+        <a:font script="Bugi" typeface="Leelawadee UI"/>
+        <a:font script="Bopo" typeface="Microsoft JhengHei"/>
+        <a:font script="Java" typeface="Javanese Text"/>
+        <a:font script="Lisu" typeface="Segoe UI"/>
+        <a:font script="Mymr" typeface="Myanmar Text"/>
+        <a:font script="Nkoo" typeface="Ebrima"/>
+        <a:font script="Olck" typeface="Nirmala UI"/>
+        <a:font script="Osma" typeface="Ebrima"/>
+        <a:font script="Phag" typeface="Phagspa"/>
+        <a:font script="Syrn" typeface="Estrangelo Edessa"/>
+        <a:font script="Syrj" typeface="Estrangelo Edessa"/>
+        <a:font script="Syre" typeface="Estrangelo Edessa"/>
+        <a:font script="Sora" typeface="Nirmala UI"/>
+        <a:font script="Tale" typeface="Microsoft Tai Le"/>
+        <a:font script="Talu" typeface="Microsoft New Tai Lue"/>
+        <a:font script="Tfng" typeface="Ebrima"/>
+      </a:minorFont>
+    </a:fontScheme>
+    <a:fmtScheme name="Office">
+      <a:fillStyleLst>
+        <a:solidFill>
+          <a:schemeClr val="phClr"/>
+        </a:solidFill>
+        <a:gradFill rotWithShape="1">
+          <a:gsLst>
+            <a:gs pos="0">
+              <a:schemeClr val="phClr">
+                <a:lumMod val="110000"/>
+                <a:satMod val="105000"/>
+                <a:tint val="67000"/>
+              </a:schemeClr>
+            </a:gs>
+            <a:gs pos="50000">
+              <a:schemeClr val="phClr">
+                <a:lumMod val="105000"/>
+                <a:satMod val="103000"/>
+                <a:tint val="73000"/>
+              </a:schemeClr>
+            </a:gs>
+            <a:gs pos="100000">
+              <a:schemeClr val="phClr">
+                <a:lumMod val="105000"/>
+                <a:satMod val="109000"/>
+                <a:tint val="81000"/>
+              </a:schemeClr>
+            </a:gs>
+          </a:gsLst>
+          <a:lin ang="5400000" scaled="0"/>
+        </a:gradFill>
+        <a:gradFill rotWithShape="1">
+          <a:gsLst>
+            <a:gs pos="0">
+              <a:schemeClr val="phClr">
+                <a:satMod val="103000"/>
+                <a:lumMod val="102000"/>
+                <a:tint val="94000"/>
+              </a:schemeClr>
+            </a:gs>
+            <a:gs pos="50000">
+              <a:schemeClr val="phClr">
+                <a:satMod val="110000"/>
+                <a:lumMod val="100000"/>
+                <a:shade val="100000"/>
+              </a:schemeClr>
+            </a:gs>
+            <a:gs pos="100000">
+              <a:schemeClr val="phClr">
+                <a:lumMod val="99000"/>
+                <a:satMod val="120000"/>
+                <a:shade val="78000"/>
+              </a:schemeClr>
+            </a:gs>
+          </a:gsLst>
+          <a:lin ang="5400000" scaled="0"/>
+        </a:gradFill>
+      </a:fillStyleLst>
+      <a:lnStyleLst>
+        <a:ln w="12700" cap="flat" cmpd="sng" algn="ctr">
+          <a:solidFill>
+            <a:schemeClr val="phClr"/>
+          </a:solidFill>
+          <a:prstDash val="solid"/>
+          <a:miter lim="800000"/>
+        </a:ln>
+        <a:ln w="19050" cap="flat" cmpd="sng" algn="ctr">
+          <a:solidFill>
+            <a:schemeClr val="phClr"/>
+          </a:solidFill>
+          <a:prstDash val="solid"/>
+          <a:miter lim="800000"/>
+        </a:ln>
+        <a:ln w="25400" cap="flat" cmpd="sng" algn="ctr">
+          <a:solidFill>
+            <a:schemeClr val="phClr"/>
+          </a:solidFill>
+          <a:prstDash val="solid"/>
+          <a:miter lim="800000"/>
+        </a:ln>
+      </a:lnStyleLst>
+      <a:effectStyleLst>
+        <a:effectStyle>
+          <a:effectLst/>
+        </a:effectStyle>
+        <a:effectStyle>
+          <a:effectLst/>
+        </a:effectStyle>
+        <a:effectStyle>
+          <a:effectLst>
+            <a:outerShdw blurRad="57150" dist="19050" dir="5400000" algn="ctr" rotWithShape="0">
+              <a:srgbClr val="000000">
+                <a:alpha val="63000"/>
+              </a:srgbClr>
+            </a:outerShdw>
+          </a:effectLst>
+        </a:effectStyle>
+      </a:effectStyleLst>
+      <a:bgFillStyleLst>
+        <a:solidFill>
+          <a:schemeClr val="phClr"/>
+        </a:solidFill>
+        <a:solidFill>
+          <a:schemeClr val="phClr">
+            <a:tint val="95000"/>
+            <a:satMod val="170000"/>
+          </a:schemeClr>
+        </a:solidFill>
+        <a:gradFill rotWithShape="1">
+          <a:gsLst>
+            <a:gs pos="0">
+              <a:schemeClr val="phClr">
+                <a:tint val="93000"/>
+                <a:satMod val="150000"/>
+                <a:shade val="98000"/>
+                <a:lumMod val="102000"/>
+              </a:schemeClr>
+            </a:gs>
+            <a:gs pos="50000">
+              <a:schemeClr val="phClr">
+                <a:tint val="98000"/>
+                <a:satMod val="130000"/>
+                <a:shade val="90000"/>
+                <a:lumMod val="103000"/>
+              </a:schemeClr>
+            </a:gs>
+            <a:gs pos="100000">
+              <a:schemeClr val="phClr">
+                <a:shade val="63000"/>
+                <a:satMod val="120000"/>
+              </a:schemeClr>
+            </a:gs>
+          </a:gsLst>
+          <a:lin ang="5400000" scaled="0"/>
+        </a:gradFill>
+      </a:bgFillStyleLst>
+    </a:fmtScheme>
+  </a:themeElements>
+  <a:objectDefaults>
+    <a:lnDef>
+      <a:spPr/>
+      <a:bodyPr/>
+      <a:lstStyle/>
+      <a:style>
+        <a:lnRef idx="2">
+          <a:schemeClr val="accent1"/>
+        </a:lnRef>
+        <a:fillRef idx="0">
+          <a:schemeClr val="accent1"/>
+        </a:fillRef>
+        <a:effectRef idx="1">
+          <a:schemeClr val="accent1"/>
+        </a:effectRef>
+        <a:fontRef idx="minor">
+          <a:schemeClr val="tx1"/>
+        </a:fontRef>
+      </a:style>
+    </a:lnDef>
+  </a:objectDefaults>
+  <a:extraClrSchemeLst/>
+  <a:extLst>
+    <a:ext uri="{05A4C25C-085E-4340-85A3-A5531E510DB2}">
+      <thm15:themeFamily xmlns:thm15="http://schemas.microsoft.com/office/thememl/2012/main" name="Office Theme" id="{2E142A2C-CD16-42D6-873A-C26D2A0506FA}" vid="{1BDDFF52-6CD6-40A5-AB3C-68EB2F1E4D0A}"/>
+    </a:ext>
+  </a:extLst>
+</a:theme>
 </file>
</xml_diff>